<commit_message>
Update PPT with TuSimple final results
</commit_message>
<xml_diff>
--- a/docs/智能驾驶车道二分类PPT设计文档.pptx
+++ b/docs/智能驾驶车道二分类PPT设计文档.pptx
@@ -5,20 +5,20 @@
     <p:sldMasterId id="2147483648" r:id="rId1"/>
   </p:sldMasterIdLst>
   <p:sldIdLst>
-    <p:sldId id="256" r:id="rId7"/>
-    <p:sldId id="257" r:id="rId8"/>
-    <p:sldId id="258" r:id="rId9"/>
-    <p:sldId id="259" r:id="rId10"/>
-    <p:sldId id="260" r:id="rId11"/>
-    <p:sldId id="261" r:id="rId12"/>
-    <p:sldId id="262" r:id="rId13"/>
-    <p:sldId id="263" r:id="rId14"/>
-    <p:sldId id="264" r:id="rId15"/>
-    <p:sldId id="265" r:id="rId16"/>
-    <p:sldId id="266" r:id="rId17"/>
-    <p:sldId id="267" r:id="rId18"/>
+    <p:sldId id="256" r:id="rId2"/>
+    <p:sldId id="257" r:id="rId3"/>
+    <p:sldId id="258" r:id="rId4"/>
+    <p:sldId id="259" r:id="rId5"/>
+    <p:sldId id="260" r:id="rId6"/>
+    <p:sldId id="261" r:id="rId7"/>
+    <p:sldId id="262" r:id="rId8"/>
+    <p:sldId id="263" r:id="rId9"/>
+    <p:sldId id="264" r:id="rId10"/>
+    <p:sldId id="265" r:id="rId11"/>
+    <p:sldId id="266" r:id="rId12"/>
+    <p:sldId id="267" r:id="rId13"/>
   </p:sldIdLst>
-  <p:sldSz cx="12191695" cy="6858000" type="screen4x3"/>
+  <p:sldSz cx="12192000" cy="6858000"/>
   <p:notesSz cx="6858000" cy="9144000"/>
   <p:defaultTextStyle>
     <a:defPPr>
@@ -115,6 +115,22 @@
       </a:defRPr>
     </a:lvl9pPr>
   </p:defaultTextStyle>
+  <p:extLst>
+    <p:ext uri="{EFAFB233-063F-42B5-8137-9DF3F51BA10A}">
+      <p15:sldGuideLst xmlns:p15="http://schemas.microsoft.com/office/powerpoint/2012/main">
+        <p15:guide id="1" orient="horz" pos="2160">
+          <p15:clr>
+            <a:srgbClr val="A4A3A4"/>
+          </p15:clr>
+        </p15:guide>
+        <p15:guide id="2" pos="2880">
+          <p15:clr>
+            <a:srgbClr val="A4A3A4"/>
+          </p15:clr>
+        </p15:guide>
+      </p15:sldGuideLst>
+    </p:ext>
+  </p:extLst>
 </p:presentation>
 </file>
 
@@ -156,10 +172,9 @@
           <a:lstStyle/>
           <a:p>
             <a:r>
-              <a:rPr lang="en-US" smtClean="0"/>
+              <a:rPr lang="en-US"/>
               <a:t>Click to edit Master title style</a:t>
             </a:r>
-            <a:endParaRPr lang="en-US"/>
           </a:p>
         </p:txBody>
       </p:sp>
@@ -275,10 +290,9 @@
           </a:lstStyle>
           <a:p>
             <a:r>
-              <a:rPr lang="en-US" smtClean="0"/>
+              <a:rPr lang="en-US"/>
               <a:t>Click to edit Master subtitle style</a:t>
             </a:r>
-            <a:endParaRPr lang="en-US"/>
           </a:p>
         </p:txBody>
       </p:sp>
@@ -299,7 +313,7 @@
           <a:p>
             <a:fld id="{5BCAD085-E8A6-8845-BD4E-CB4CCA059FC4}" type="datetimeFigureOut">
               <a:rPr lang="en-US" smtClean="0"/>
-              <a:t>1/27/13</a:t>
+              <a:t>6/28/2026</a:t>
             </a:fld>
             <a:endParaRPr lang="en-US"/>
           </a:p>
@@ -393,10 +407,9 @@
           <a:lstStyle/>
           <a:p>
             <a:r>
-              <a:rPr lang="en-US" smtClean="0"/>
+              <a:rPr lang="en-US"/>
               <a:t>Click to edit Master title style</a:t>
             </a:r>
-            <a:endParaRPr lang="en-US"/>
           </a:p>
         </p:txBody>
       </p:sp>
@@ -417,38 +430,37 @@
           <a:p>
             <a:pPr lvl="0"/>
             <a:r>
-              <a:rPr lang="en-US" smtClean="0"/>
+              <a:rPr lang="en-US"/>
               <a:t>Click to edit Master text styles</a:t>
             </a:r>
           </a:p>
           <a:p>
             <a:pPr lvl="1"/>
             <a:r>
-              <a:rPr lang="en-US" smtClean="0"/>
+              <a:rPr lang="en-US"/>
               <a:t>Second level</a:t>
             </a:r>
           </a:p>
           <a:p>
             <a:pPr lvl="2"/>
             <a:r>
-              <a:rPr lang="en-US" smtClean="0"/>
+              <a:rPr lang="en-US"/>
               <a:t>Third level</a:t>
             </a:r>
           </a:p>
           <a:p>
             <a:pPr lvl="3"/>
             <a:r>
-              <a:rPr lang="en-US" smtClean="0"/>
+              <a:rPr lang="en-US"/>
               <a:t>Fourth level</a:t>
             </a:r>
           </a:p>
           <a:p>
             <a:pPr lvl="4"/>
             <a:r>
-              <a:rPr lang="en-US" smtClean="0"/>
+              <a:rPr lang="en-US"/>
               <a:t>Fifth level</a:t>
             </a:r>
-            <a:endParaRPr lang="en-US"/>
           </a:p>
         </p:txBody>
       </p:sp>
@@ -469,7 +481,7 @@
           <a:p>
             <a:fld id="{5BCAD085-E8A6-8845-BD4E-CB4CCA059FC4}" type="datetimeFigureOut">
               <a:rPr lang="en-US" smtClean="0"/>
-              <a:t>1/27/13</a:t>
+              <a:t>6/28/2026</a:t>
             </a:fld>
             <a:endParaRPr lang="en-US"/>
           </a:p>
@@ -568,10 +580,9 @@
           <a:lstStyle/>
           <a:p>
             <a:r>
-              <a:rPr lang="en-US" smtClean="0"/>
+              <a:rPr lang="en-US"/>
               <a:t>Click to edit Master title style</a:t>
             </a:r>
-            <a:endParaRPr lang="en-US"/>
           </a:p>
         </p:txBody>
       </p:sp>
@@ -597,38 +608,37 @@
           <a:p>
             <a:pPr lvl="0"/>
             <a:r>
-              <a:rPr lang="en-US" smtClean="0"/>
+              <a:rPr lang="en-US"/>
               <a:t>Click to edit Master text styles</a:t>
             </a:r>
           </a:p>
           <a:p>
             <a:pPr lvl="1"/>
             <a:r>
-              <a:rPr lang="en-US" smtClean="0"/>
+              <a:rPr lang="en-US"/>
               <a:t>Second level</a:t>
             </a:r>
           </a:p>
           <a:p>
             <a:pPr lvl="2"/>
             <a:r>
-              <a:rPr lang="en-US" smtClean="0"/>
+              <a:rPr lang="en-US"/>
               <a:t>Third level</a:t>
             </a:r>
           </a:p>
           <a:p>
             <a:pPr lvl="3"/>
             <a:r>
-              <a:rPr lang="en-US" smtClean="0"/>
+              <a:rPr lang="en-US"/>
               <a:t>Fourth level</a:t>
             </a:r>
           </a:p>
           <a:p>
             <a:pPr lvl="4"/>
             <a:r>
-              <a:rPr lang="en-US" smtClean="0"/>
+              <a:rPr lang="en-US"/>
               <a:t>Fifth level</a:t>
             </a:r>
-            <a:endParaRPr lang="en-US"/>
           </a:p>
         </p:txBody>
       </p:sp>
@@ -649,7 +659,7 @@
           <a:p>
             <a:fld id="{5BCAD085-E8A6-8845-BD4E-CB4CCA059FC4}" type="datetimeFigureOut">
               <a:rPr lang="en-US" smtClean="0"/>
-              <a:t>1/27/13</a:t>
+              <a:t>6/28/2026</a:t>
             </a:fld>
             <a:endParaRPr lang="en-US"/>
           </a:p>
@@ -743,10 +753,9 @@
           <a:lstStyle/>
           <a:p>
             <a:r>
-              <a:rPr lang="en-US" smtClean="0"/>
+              <a:rPr lang="en-US"/>
               <a:t>Click to edit Master title style</a:t>
             </a:r>
-            <a:endParaRPr lang="en-US"/>
           </a:p>
         </p:txBody>
       </p:sp>
@@ -767,38 +776,37 @@
           <a:p>
             <a:pPr lvl="0"/>
             <a:r>
-              <a:rPr lang="en-US" smtClean="0"/>
+              <a:rPr lang="en-US"/>
               <a:t>Click to edit Master text styles</a:t>
             </a:r>
           </a:p>
           <a:p>
             <a:pPr lvl="1"/>
             <a:r>
-              <a:rPr lang="en-US" smtClean="0"/>
+              <a:rPr lang="en-US"/>
               <a:t>Second level</a:t>
             </a:r>
           </a:p>
           <a:p>
             <a:pPr lvl="2"/>
             <a:r>
-              <a:rPr lang="en-US" smtClean="0"/>
+              <a:rPr lang="en-US"/>
               <a:t>Third level</a:t>
             </a:r>
           </a:p>
           <a:p>
             <a:pPr lvl="3"/>
             <a:r>
-              <a:rPr lang="en-US" smtClean="0"/>
+              <a:rPr lang="en-US"/>
               <a:t>Fourth level</a:t>
             </a:r>
           </a:p>
           <a:p>
             <a:pPr lvl="4"/>
             <a:r>
-              <a:rPr lang="en-US" smtClean="0"/>
+              <a:rPr lang="en-US"/>
               <a:t>Fifth level</a:t>
             </a:r>
-            <a:endParaRPr lang="en-US"/>
           </a:p>
         </p:txBody>
       </p:sp>
@@ -819,7 +827,7 @@
           <a:p>
             <a:fld id="{5BCAD085-E8A6-8845-BD4E-CB4CCA059FC4}" type="datetimeFigureOut">
               <a:rPr lang="en-US" smtClean="0"/>
-              <a:t>1/27/13</a:t>
+              <a:t>6/28/2026</a:t>
             </a:fld>
             <a:endParaRPr lang="en-US"/>
           </a:p>
@@ -922,10 +930,9 @@
           </a:lstStyle>
           <a:p>
             <a:r>
-              <a:rPr lang="en-US" smtClean="0"/>
+              <a:rPr lang="en-US"/>
               <a:t>Click to edit Master title style</a:t>
             </a:r>
-            <a:endParaRPr lang="en-US"/>
           </a:p>
         </p:txBody>
       </p:sp>
@@ -1042,7 +1049,7 @@
           <a:p>
             <a:pPr lvl="0"/>
             <a:r>
-              <a:rPr lang="en-US" smtClean="0"/>
+              <a:rPr lang="en-US"/>
               <a:t>Click to edit Master text styles</a:t>
             </a:r>
           </a:p>
@@ -1065,7 +1072,7 @@
           <a:p>
             <a:fld id="{5BCAD085-E8A6-8845-BD4E-CB4CCA059FC4}" type="datetimeFigureOut">
               <a:rPr lang="en-US" smtClean="0"/>
-              <a:t>1/27/13</a:t>
+              <a:t>6/28/2026</a:t>
             </a:fld>
             <a:endParaRPr lang="en-US"/>
           </a:p>
@@ -1159,10 +1166,9 @@
           <a:lstStyle/>
           <a:p>
             <a:r>
-              <a:rPr lang="en-US" smtClean="0"/>
+              <a:rPr lang="en-US"/>
               <a:t>Click to edit Master title style</a:t>
             </a:r>
-            <a:endParaRPr lang="en-US"/>
           </a:p>
         </p:txBody>
       </p:sp>
@@ -1216,38 +1222,37 @@
           <a:p>
             <a:pPr lvl="0"/>
             <a:r>
-              <a:rPr lang="en-US" smtClean="0"/>
+              <a:rPr lang="en-US"/>
               <a:t>Click to edit Master text styles</a:t>
             </a:r>
           </a:p>
           <a:p>
             <a:pPr lvl="1"/>
             <a:r>
-              <a:rPr lang="en-US" smtClean="0"/>
+              <a:rPr lang="en-US"/>
               <a:t>Second level</a:t>
             </a:r>
           </a:p>
           <a:p>
             <a:pPr lvl="2"/>
             <a:r>
-              <a:rPr lang="en-US" smtClean="0"/>
+              <a:rPr lang="en-US"/>
               <a:t>Third level</a:t>
             </a:r>
           </a:p>
           <a:p>
             <a:pPr lvl="3"/>
             <a:r>
-              <a:rPr lang="en-US" smtClean="0"/>
+              <a:rPr lang="en-US"/>
               <a:t>Fourth level</a:t>
             </a:r>
           </a:p>
           <a:p>
             <a:pPr lvl="4"/>
             <a:r>
-              <a:rPr lang="en-US" smtClean="0"/>
+              <a:rPr lang="en-US"/>
               <a:t>Fifth level</a:t>
             </a:r>
-            <a:endParaRPr lang="en-US"/>
           </a:p>
         </p:txBody>
       </p:sp>
@@ -1301,38 +1306,37 @@
           <a:p>
             <a:pPr lvl="0"/>
             <a:r>
-              <a:rPr lang="en-US" smtClean="0"/>
+              <a:rPr lang="en-US"/>
               <a:t>Click to edit Master text styles</a:t>
             </a:r>
           </a:p>
           <a:p>
             <a:pPr lvl="1"/>
             <a:r>
-              <a:rPr lang="en-US" smtClean="0"/>
+              <a:rPr lang="en-US"/>
               <a:t>Second level</a:t>
             </a:r>
           </a:p>
           <a:p>
             <a:pPr lvl="2"/>
             <a:r>
-              <a:rPr lang="en-US" smtClean="0"/>
+              <a:rPr lang="en-US"/>
               <a:t>Third level</a:t>
             </a:r>
           </a:p>
           <a:p>
             <a:pPr lvl="3"/>
             <a:r>
-              <a:rPr lang="en-US" smtClean="0"/>
+              <a:rPr lang="en-US"/>
               <a:t>Fourth level</a:t>
             </a:r>
           </a:p>
           <a:p>
             <a:pPr lvl="4"/>
             <a:r>
-              <a:rPr lang="en-US" smtClean="0"/>
+              <a:rPr lang="en-US"/>
               <a:t>Fifth level</a:t>
             </a:r>
-            <a:endParaRPr lang="en-US"/>
           </a:p>
         </p:txBody>
       </p:sp>
@@ -1353,7 +1357,7 @@
           <a:p>
             <a:fld id="{5BCAD085-E8A6-8845-BD4E-CB4CCA059FC4}" type="datetimeFigureOut">
               <a:rPr lang="en-US" smtClean="0"/>
-              <a:t>1/27/13</a:t>
+              <a:t>6/28/2026</a:t>
             </a:fld>
             <a:endParaRPr lang="en-US"/>
           </a:p>
@@ -1451,10 +1455,9 @@
           </a:lstStyle>
           <a:p>
             <a:r>
-              <a:rPr lang="en-US" smtClean="0"/>
+              <a:rPr lang="en-US"/>
               <a:t>Click to edit Master title style</a:t>
             </a:r>
-            <a:endParaRPr lang="en-US"/>
           </a:p>
         </p:txBody>
       </p:sp>
@@ -1517,7 +1520,7 @@
           <a:p>
             <a:pPr lvl="0"/>
             <a:r>
-              <a:rPr lang="en-US" smtClean="0"/>
+              <a:rPr lang="en-US"/>
               <a:t>Click to edit Master text styles</a:t>
             </a:r>
           </a:p>
@@ -1573,38 +1576,37 @@
           <a:p>
             <a:pPr lvl="0"/>
             <a:r>
-              <a:rPr lang="en-US" smtClean="0"/>
+              <a:rPr lang="en-US"/>
               <a:t>Click to edit Master text styles</a:t>
             </a:r>
           </a:p>
           <a:p>
             <a:pPr lvl="1"/>
             <a:r>
-              <a:rPr lang="en-US" smtClean="0"/>
+              <a:rPr lang="en-US"/>
               <a:t>Second level</a:t>
             </a:r>
           </a:p>
           <a:p>
             <a:pPr lvl="2"/>
             <a:r>
-              <a:rPr lang="en-US" smtClean="0"/>
+              <a:rPr lang="en-US"/>
               <a:t>Third level</a:t>
             </a:r>
           </a:p>
           <a:p>
             <a:pPr lvl="3"/>
             <a:r>
-              <a:rPr lang="en-US" smtClean="0"/>
+              <a:rPr lang="en-US"/>
               <a:t>Fourth level</a:t>
             </a:r>
           </a:p>
           <a:p>
             <a:pPr lvl="4"/>
             <a:r>
-              <a:rPr lang="en-US" smtClean="0"/>
+              <a:rPr lang="en-US"/>
               <a:t>Fifth level</a:t>
             </a:r>
-            <a:endParaRPr lang="en-US"/>
           </a:p>
         </p:txBody>
       </p:sp>
@@ -1667,7 +1669,7 @@
           <a:p>
             <a:pPr lvl="0"/>
             <a:r>
-              <a:rPr lang="en-US" smtClean="0"/>
+              <a:rPr lang="en-US"/>
               <a:t>Click to edit Master text styles</a:t>
             </a:r>
           </a:p>
@@ -1723,38 +1725,37 @@
           <a:p>
             <a:pPr lvl="0"/>
             <a:r>
-              <a:rPr lang="en-US" smtClean="0"/>
+              <a:rPr lang="en-US"/>
               <a:t>Click to edit Master text styles</a:t>
             </a:r>
           </a:p>
           <a:p>
             <a:pPr lvl="1"/>
             <a:r>
-              <a:rPr lang="en-US" smtClean="0"/>
+              <a:rPr lang="en-US"/>
               <a:t>Second level</a:t>
             </a:r>
           </a:p>
           <a:p>
             <a:pPr lvl="2"/>
             <a:r>
-              <a:rPr lang="en-US" smtClean="0"/>
+              <a:rPr lang="en-US"/>
               <a:t>Third level</a:t>
             </a:r>
           </a:p>
           <a:p>
             <a:pPr lvl="3"/>
             <a:r>
-              <a:rPr lang="en-US" smtClean="0"/>
+              <a:rPr lang="en-US"/>
               <a:t>Fourth level</a:t>
             </a:r>
           </a:p>
           <a:p>
             <a:pPr lvl="4"/>
             <a:r>
-              <a:rPr lang="en-US" smtClean="0"/>
+              <a:rPr lang="en-US"/>
               <a:t>Fifth level</a:t>
             </a:r>
-            <a:endParaRPr lang="en-US"/>
           </a:p>
         </p:txBody>
       </p:sp>
@@ -1775,7 +1776,7 @@
           <a:p>
             <a:fld id="{5BCAD085-E8A6-8845-BD4E-CB4CCA059FC4}" type="datetimeFigureOut">
               <a:rPr lang="en-US" smtClean="0"/>
-              <a:t>1/27/13</a:t>
+              <a:t>6/28/2026</a:t>
             </a:fld>
             <a:endParaRPr lang="en-US"/>
           </a:p>
@@ -1869,10 +1870,9 @@
           <a:lstStyle/>
           <a:p>
             <a:r>
-              <a:rPr lang="en-US" smtClean="0"/>
+              <a:rPr lang="en-US"/>
               <a:t>Click to edit Master title style</a:t>
             </a:r>
-            <a:endParaRPr lang="en-US"/>
           </a:p>
         </p:txBody>
       </p:sp>
@@ -1893,7 +1893,7 @@
           <a:p>
             <a:fld id="{5BCAD085-E8A6-8845-BD4E-CB4CCA059FC4}" type="datetimeFigureOut">
               <a:rPr lang="en-US" smtClean="0"/>
-              <a:t>1/27/13</a:t>
+              <a:t>6/28/2026</a:t>
             </a:fld>
             <a:endParaRPr lang="en-US"/>
           </a:p>
@@ -1988,7 +1988,7 @@
           <a:p>
             <a:fld id="{5BCAD085-E8A6-8845-BD4E-CB4CCA059FC4}" type="datetimeFigureOut">
               <a:rPr lang="en-US" smtClean="0"/>
-              <a:t>1/27/13</a:t>
+              <a:t>6/28/2026</a:t>
             </a:fld>
             <a:endParaRPr lang="en-US"/>
           </a:p>
@@ -2091,10 +2091,9 @@
           </a:lstStyle>
           <a:p>
             <a:r>
-              <a:rPr lang="en-US" smtClean="0"/>
+              <a:rPr lang="en-US"/>
               <a:t>Click to edit Master title style</a:t>
             </a:r>
-            <a:endParaRPr lang="en-US"/>
           </a:p>
         </p:txBody>
       </p:sp>
@@ -2148,38 +2147,37 @@
           <a:p>
             <a:pPr lvl="0"/>
             <a:r>
-              <a:rPr lang="en-US" smtClean="0"/>
+              <a:rPr lang="en-US"/>
               <a:t>Click to edit Master text styles</a:t>
             </a:r>
           </a:p>
           <a:p>
             <a:pPr lvl="1"/>
             <a:r>
-              <a:rPr lang="en-US" smtClean="0"/>
+              <a:rPr lang="en-US"/>
               <a:t>Second level</a:t>
             </a:r>
           </a:p>
           <a:p>
             <a:pPr lvl="2"/>
             <a:r>
-              <a:rPr lang="en-US" smtClean="0"/>
+              <a:rPr lang="en-US"/>
               <a:t>Third level</a:t>
             </a:r>
           </a:p>
           <a:p>
             <a:pPr lvl="3"/>
             <a:r>
-              <a:rPr lang="en-US" smtClean="0"/>
+              <a:rPr lang="en-US"/>
               <a:t>Fourth level</a:t>
             </a:r>
           </a:p>
           <a:p>
             <a:pPr lvl="4"/>
             <a:r>
-              <a:rPr lang="en-US" smtClean="0"/>
+              <a:rPr lang="en-US"/>
               <a:t>Fifth level</a:t>
             </a:r>
-            <a:endParaRPr lang="en-US"/>
           </a:p>
         </p:txBody>
       </p:sp>
@@ -2242,7 +2240,7 @@
           <a:p>
             <a:pPr lvl="0"/>
             <a:r>
-              <a:rPr lang="en-US" smtClean="0"/>
+              <a:rPr lang="en-US"/>
               <a:t>Click to edit Master text styles</a:t>
             </a:r>
           </a:p>
@@ -2265,7 +2263,7 @@
           <a:p>
             <a:fld id="{5BCAD085-E8A6-8845-BD4E-CB4CCA059FC4}" type="datetimeFigureOut">
               <a:rPr lang="en-US" smtClean="0"/>
-              <a:t>1/27/13</a:t>
+              <a:t>6/28/2026</a:t>
             </a:fld>
             <a:endParaRPr lang="en-US"/>
           </a:p>
@@ -2368,10 +2366,9 @@
           </a:lstStyle>
           <a:p>
             <a:r>
-              <a:rPr lang="en-US" smtClean="0"/>
+              <a:rPr lang="en-US"/>
               <a:t>Click to edit Master title style</a:t>
             </a:r>
-            <a:endParaRPr lang="en-US"/>
           </a:p>
         </p:txBody>
       </p:sp>
@@ -2495,7 +2492,7 @@
           <a:p>
             <a:pPr lvl="0"/>
             <a:r>
-              <a:rPr lang="en-US" smtClean="0"/>
+              <a:rPr lang="en-US"/>
               <a:t>Click to edit Master text styles</a:t>
             </a:r>
           </a:p>
@@ -2518,7 +2515,7 @@
           <a:p>
             <a:fld id="{5BCAD085-E8A6-8845-BD4E-CB4CCA059FC4}" type="datetimeFigureOut">
               <a:rPr lang="en-US" smtClean="0"/>
-              <a:t>1/27/13</a:t>
+              <a:t>6/28/2026</a:t>
             </a:fld>
             <a:endParaRPr lang="en-US"/>
           </a:p>
@@ -2627,10 +2624,9 @@
           <a:lstStyle/>
           <a:p>
             <a:r>
-              <a:rPr lang="en-US" smtClean="0"/>
+              <a:rPr lang="en-US"/>
               <a:t>Click to edit Master title style</a:t>
             </a:r>
-            <a:endParaRPr lang="en-US"/>
           </a:p>
         </p:txBody>
       </p:sp>
@@ -2661,38 +2657,37 @@
           <a:p>
             <a:pPr lvl="0"/>
             <a:r>
-              <a:rPr lang="en-US" smtClean="0"/>
+              <a:rPr lang="en-US"/>
               <a:t>Click to edit Master text styles</a:t>
             </a:r>
           </a:p>
           <a:p>
             <a:pPr lvl="1"/>
             <a:r>
-              <a:rPr lang="en-US" smtClean="0"/>
+              <a:rPr lang="en-US"/>
               <a:t>Second level</a:t>
             </a:r>
           </a:p>
           <a:p>
             <a:pPr lvl="2"/>
             <a:r>
-              <a:rPr lang="en-US" smtClean="0"/>
+              <a:rPr lang="en-US"/>
               <a:t>Third level</a:t>
             </a:r>
           </a:p>
           <a:p>
             <a:pPr lvl="3"/>
             <a:r>
-              <a:rPr lang="en-US" smtClean="0"/>
+              <a:rPr lang="en-US"/>
               <a:t>Fourth level</a:t>
             </a:r>
           </a:p>
           <a:p>
             <a:pPr lvl="4"/>
             <a:r>
-              <a:rPr lang="en-US" smtClean="0"/>
+              <a:rPr lang="en-US"/>
               <a:t>Fifth level</a:t>
             </a:r>
-            <a:endParaRPr lang="en-US"/>
           </a:p>
         </p:txBody>
       </p:sp>
@@ -2731,7 +2726,7 @@
           <a:p>
             <a:fld id="{5BCAD085-E8A6-8845-BD4E-CB4CCA059FC4}" type="datetimeFigureOut">
               <a:rPr lang="en-US" smtClean="0"/>
-              <a:t>1/27/13</a:t>
+              <a:t>6/28/2026</a:t>
             </a:fld>
             <a:endParaRPr lang="en-US"/>
           </a:p>
@@ -3090,7 +3085,7 @@
 </file>
 
 <file path=ppt/slides/slide1.xml><?xml version="1.0" encoding="utf-8"?>
-<p:sld xmlns:a="http://schemas.openxmlformats.org/drawingml/2006/main" xmlns:p="http://schemas.openxmlformats.org/presentationml/2006/main" xmlns:r="http://schemas.openxmlformats.org/officeDocument/2006/relationships">
+<p:sld xmlns:a="http://schemas.openxmlformats.org/drawingml/2006/main" xmlns:r="http://schemas.openxmlformats.org/officeDocument/2006/relationships" xmlns:p="http://schemas.openxmlformats.org/presentationml/2006/main">
   <p:cSld>
     <p:bg>
       <p:bgPr>
@@ -3106,7 +3101,14 @@
         <p:cNvGrpSpPr/>
         <p:nvPr/>
       </p:nvGrpSpPr>
-      <p:grpSpPr/>
+      <p:grpSpPr>
+        <a:xfrm>
+          <a:off x="0" y="0"/>
+          <a:ext cx="0" cy="0"/>
+          <a:chOff x="0" y="0"/>
+          <a:chExt cx="0" cy="0"/>
+        </a:xfrm>
+      </p:grpSpPr>
       <p:sp>
         <p:nvSpPr>
           <p:cNvPr id="2" name="Rounded Rectangle 1"/>
@@ -3320,6 +3322,7 @@
           <a:lstStyle/>
           <a:p>
             <a:pPr algn="ctr"/>
+            <a:endParaRPr/>
           </a:p>
         </p:txBody>
       </p:sp>
@@ -3415,6 +3418,7 @@
           <a:lstStyle/>
           <a:p>
             <a:pPr algn="ctr"/>
+            <a:endParaRPr/>
           </a:p>
         </p:txBody>
       </p:sp>
@@ -3510,6 +3514,7 @@
           <a:lstStyle/>
           <a:p>
             <a:pPr algn="ctr"/>
+            <a:endParaRPr/>
           </a:p>
         </p:txBody>
       </p:sp>
@@ -3605,6 +3610,7 @@
           <a:lstStyle/>
           <a:p>
             <a:pPr algn="ctr"/>
+            <a:endParaRPr/>
           </a:p>
         </p:txBody>
       </p:sp>
@@ -3700,6 +3706,7 @@
           <a:lstStyle/>
           <a:p>
             <a:pPr algn="ctr"/>
+            <a:endParaRPr/>
           </a:p>
         </p:txBody>
       </p:sp>
@@ -3795,6 +3802,7 @@
           <a:lstStyle/>
           <a:p>
             <a:pPr algn="ctr"/>
+            <a:endParaRPr/>
           </a:p>
         </p:txBody>
       </p:sp>
@@ -3842,7 +3850,7 @@
 </file>
 
 <file path=ppt/slides/slide10.xml><?xml version="1.0" encoding="utf-8"?>
-<p:sld xmlns:a="http://schemas.openxmlformats.org/drawingml/2006/main" xmlns:p="http://schemas.openxmlformats.org/presentationml/2006/main" xmlns:r="http://schemas.openxmlformats.org/officeDocument/2006/relationships">
+<p:sld xmlns:a="http://schemas.openxmlformats.org/drawingml/2006/main" xmlns:r="http://schemas.openxmlformats.org/officeDocument/2006/relationships" xmlns:p="http://schemas.openxmlformats.org/presentationml/2006/main">
   <p:cSld>
     <p:bg>
       <p:bgPr>
@@ -3858,7 +3866,14 @@
         <p:cNvGrpSpPr/>
         <p:nvPr/>
       </p:nvGrpSpPr>
-      <p:grpSpPr/>
+      <p:grpSpPr>
+        <a:xfrm>
+          <a:off x="0" y="0"/>
+          <a:ext cx="0" cy="0"/>
+          <a:chOff x="0" y="0"/>
+          <a:chExt cx="0" cy="0"/>
+        </a:xfrm>
+      </p:grpSpPr>
       <p:sp>
         <p:nvSpPr>
           <p:cNvPr id="2" name="TextBox 1"/>
@@ -3969,6 +3984,7 @@
           <a:lstStyle/>
           <a:p>
             <a:pPr algn="ctr"/>
+            <a:endParaRPr/>
           </a:p>
         </p:txBody>
       </p:sp>
@@ -4467,6 +4483,7 @@
           <a:lstStyle/>
           <a:p>
             <a:pPr algn="ctr"/>
+            <a:endParaRPr/>
           </a:p>
         </p:txBody>
       </p:sp>
@@ -4514,7 +4531,7 @@
 </file>
 
 <file path=ppt/slides/slide11.xml><?xml version="1.0" encoding="utf-8"?>
-<p:sld xmlns:a="http://schemas.openxmlformats.org/drawingml/2006/main" xmlns:p="http://schemas.openxmlformats.org/presentationml/2006/main" xmlns:r="http://schemas.openxmlformats.org/officeDocument/2006/relationships">
+<p:sld xmlns:a="http://schemas.openxmlformats.org/drawingml/2006/main" xmlns:r="http://schemas.openxmlformats.org/officeDocument/2006/relationships" xmlns:p="http://schemas.openxmlformats.org/presentationml/2006/main">
   <p:cSld>
     <p:bg>
       <p:bgPr>
@@ -4530,7 +4547,14 @@
         <p:cNvGrpSpPr/>
         <p:nvPr/>
       </p:nvGrpSpPr>
-      <p:grpSpPr/>
+      <p:grpSpPr>
+        <a:xfrm>
+          <a:off x="0" y="0"/>
+          <a:ext cx="0" cy="0"/>
+          <a:chOff x="0" y="0"/>
+          <a:chExt cx="0" cy="0"/>
+        </a:xfrm>
+      </p:grpSpPr>
       <p:sp>
         <p:nvSpPr>
           <p:cNvPr id="2" name="TextBox 1"/>
@@ -4641,6 +4665,7 @@
           <a:lstStyle/>
           <a:p>
             <a:pPr algn="ctr"/>
+            <a:endParaRPr/>
           </a:p>
         </p:txBody>
       </p:sp>
@@ -4823,6 +4848,7 @@
           <a:lstStyle/>
           <a:p>
             <a:pPr algn="ctr"/>
+            <a:endParaRPr/>
           </a:p>
         </p:txBody>
       </p:sp>
@@ -5003,6 +5029,7 @@
           <a:lstStyle/>
           <a:p>
             <a:pPr algn="ctr"/>
+            <a:endParaRPr/>
           </a:p>
         </p:txBody>
       </p:sp>
@@ -5050,7 +5077,7 @@
 </file>
 
 <file path=ppt/slides/slide12.xml><?xml version="1.0" encoding="utf-8"?>
-<p:sld xmlns:a="http://schemas.openxmlformats.org/drawingml/2006/main" xmlns:p="http://schemas.openxmlformats.org/presentationml/2006/main" xmlns:r="http://schemas.openxmlformats.org/officeDocument/2006/relationships">
+<p:sld xmlns:a="http://schemas.openxmlformats.org/drawingml/2006/main" xmlns:r="http://schemas.openxmlformats.org/officeDocument/2006/relationships" xmlns:p="http://schemas.openxmlformats.org/presentationml/2006/main">
   <p:cSld>
     <p:bg>
       <p:bgPr>
@@ -5066,7 +5093,14 @@
         <p:cNvGrpSpPr/>
         <p:nvPr/>
       </p:nvGrpSpPr>
-      <p:grpSpPr/>
+      <p:grpSpPr>
+        <a:xfrm>
+          <a:off x="0" y="0"/>
+          <a:ext cx="0" cy="0"/>
+          <a:chOff x="0" y="0"/>
+          <a:chExt cx="0" cy="0"/>
+        </a:xfrm>
+      </p:grpSpPr>
       <p:sp>
         <p:nvSpPr>
           <p:cNvPr id="2" name="TextBox 1"/>
@@ -5177,6 +5211,7 @@
           <a:lstStyle/>
           <a:p>
             <a:pPr algn="ctr"/>
+            <a:endParaRPr/>
           </a:p>
         </p:txBody>
       </p:sp>
@@ -5359,6 +5394,7 @@
           <a:lstStyle/>
           <a:p>
             <a:pPr algn="ctr"/>
+            <a:endParaRPr/>
           </a:p>
         </p:txBody>
       </p:sp>
@@ -5539,6 +5575,7 @@
           <a:lstStyle/>
           <a:p>
             <a:pPr algn="ctr"/>
+            <a:endParaRPr/>
           </a:p>
         </p:txBody>
       </p:sp>
@@ -5586,7 +5623,7 @@
 </file>
 
 <file path=ppt/slides/slide2.xml><?xml version="1.0" encoding="utf-8"?>
-<p:sld xmlns:a="http://schemas.openxmlformats.org/drawingml/2006/main" xmlns:p="http://schemas.openxmlformats.org/presentationml/2006/main" xmlns:r="http://schemas.openxmlformats.org/officeDocument/2006/relationships">
+<p:sld xmlns:a="http://schemas.openxmlformats.org/drawingml/2006/main" xmlns:r="http://schemas.openxmlformats.org/officeDocument/2006/relationships" xmlns:p="http://schemas.openxmlformats.org/presentationml/2006/main">
   <p:cSld>
     <p:bg>
       <p:bgPr>
@@ -5602,7 +5639,14 @@
         <p:cNvGrpSpPr/>
         <p:nvPr/>
       </p:nvGrpSpPr>
-      <p:grpSpPr/>
+      <p:grpSpPr>
+        <a:xfrm>
+          <a:off x="0" y="0"/>
+          <a:ext cx="0" cy="0"/>
+          <a:chOff x="0" y="0"/>
+          <a:chExt cx="0" cy="0"/>
+        </a:xfrm>
+      </p:grpSpPr>
       <p:sp>
         <p:nvSpPr>
           <p:cNvPr id="2" name="TextBox 1"/>
@@ -5713,6 +5757,7 @@
           <a:lstStyle/>
           <a:p>
             <a:pPr algn="ctr"/>
+            <a:endParaRPr/>
           </a:p>
         </p:txBody>
       </p:sp>
@@ -5879,6 +5924,7 @@
           <a:lstStyle/>
           <a:p>
             <a:pPr algn="ctr"/>
+            <a:endParaRPr/>
           </a:p>
         </p:txBody>
       </p:sp>
@@ -5925,7 +5971,7 @@
         <p:spPr>
           <a:xfrm>
             <a:off x="6537960" y="1874519"/>
-            <a:ext cx="4663440" cy="3383280"/>
+            <a:ext cx="4663440" cy="938719"/>
           </a:xfrm>
           <a:prstGeom prst="rect">
             <a:avLst/>
@@ -5950,8 +5996,18 @@
               </a:defRPr>
             </a:pPr>
             <a:r>
-              <a:t>可上传 GitHub 的标准工程结构</a:t>
-            </a:r>
+              <a:rPr dirty="0" err="1"/>
+              <a:t>可上传</a:t>
+            </a:r>
+            <a:r>
+              <a:rPr dirty="0"/>
+              <a:t> GitHub </a:t>
+            </a:r>
+            <a:r>
+              <a:rPr dirty="0" err="1"/>
+              <a:t>的标准工程结构</a:t>
+            </a:r>
+            <a:endParaRPr dirty="0"/>
           </a:p>
           <a:p>
             <a:pPr>
@@ -5966,8 +6022,10 @@
               </a:defRPr>
             </a:pPr>
             <a:r>
+              <a:rPr dirty="0" err="1"/>
               <a:t>训练、推理、导出和数据转换脚本</a:t>
             </a:r>
+            <a:endParaRPr dirty="0"/>
           </a:p>
           <a:p>
             <a:pPr>
@@ -5982,24 +6040,18 @@
               </a:defRPr>
             </a:pPr>
             <a:r>
-              <a:t>实验报告 Word 与 PPT 设计文档</a:t>
-            </a:r>
-          </a:p>
-          <a:p>
-            <a:pPr>
-              <a:spcAft>
-                <a:spcPts val="600"/>
-              </a:spcAft>
-              <a:defRPr sz="1500">
-                <a:solidFill>
-                  <a:srgbClr val="141F2B"/>
-                </a:solidFill>
-                <a:latin typeface="Microsoft YaHei"/>
-              </a:defRPr>
-            </a:pPr>
-            <a:r>
-              <a:t>后续可替换为 TuSimple 真实训练结果</a:t>
-            </a:r>
+              <a:rPr dirty="0" err="1"/>
+              <a:t>实验报告</a:t>
+            </a:r>
+            <a:r>
+              <a:rPr dirty="0"/>
+              <a:t> Word 与 PPT </a:t>
+            </a:r>
+            <a:r>
+              <a:rPr dirty="0" err="1"/>
+              <a:t>设计文档</a:t>
+            </a:r>
+            <a:endParaRPr dirty="0"/>
           </a:p>
         </p:txBody>
       </p:sp>
@@ -6043,6 +6095,7 @@
           <a:lstStyle/>
           <a:p>
             <a:pPr algn="ctr"/>
+            <a:endParaRPr/>
           </a:p>
         </p:txBody>
       </p:sp>
@@ -6090,7 +6143,7 @@
 </file>
 
 <file path=ppt/slides/slide3.xml><?xml version="1.0" encoding="utf-8"?>
-<p:sld xmlns:a="http://schemas.openxmlformats.org/drawingml/2006/main" xmlns:p="http://schemas.openxmlformats.org/presentationml/2006/main" xmlns:r="http://schemas.openxmlformats.org/officeDocument/2006/relationships">
+<p:sld xmlns:a="http://schemas.openxmlformats.org/drawingml/2006/main" xmlns:r="http://schemas.openxmlformats.org/officeDocument/2006/relationships" xmlns:p="http://schemas.openxmlformats.org/presentationml/2006/main">
   <p:cSld>
     <p:bg>
       <p:bgPr>
@@ -6106,7 +6159,14 @@
         <p:cNvGrpSpPr/>
         <p:nvPr/>
       </p:nvGrpSpPr>
-      <p:grpSpPr/>
+      <p:grpSpPr>
+        <a:xfrm>
+          <a:off x="0" y="0"/>
+          <a:ext cx="0" cy="0"/>
+          <a:chOff x="0" y="0"/>
+          <a:chExt cx="0" cy="0"/>
+        </a:xfrm>
+      </p:grpSpPr>
       <p:sp>
         <p:nvSpPr>
           <p:cNvPr id="2" name="TextBox 1"/>
@@ -6268,6 +6328,7 @@
           <a:lstStyle/>
           <a:p>
             <a:pPr algn="ctr"/>
+            <a:endParaRPr/>
           </a:p>
         </p:txBody>
       </p:sp>
@@ -6364,6 +6425,7 @@
           <a:lstStyle/>
           <a:p>
             <a:pPr algn="ctr"/>
+            <a:endParaRPr/>
           </a:p>
         </p:txBody>
       </p:sp>
@@ -6460,6 +6522,7 @@
           <a:lstStyle/>
           <a:p>
             <a:pPr algn="ctr"/>
+            <a:endParaRPr/>
           </a:p>
         </p:txBody>
       </p:sp>
@@ -6556,6 +6619,7 @@
           <a:lstStyle/>
           <a:p>
             <a:pPr algn="ctr"/>
+            <a:endParaRPr/>
           </a:p>
         </p:txBody>
       </p:sp>
@@ -6652,6 +6716,7 @@
           <a:lstStyle/>
           <a:p>
             <a:pPr algn="ctr"/>
+            <a:endParaRPr/>
           </a:p>
         </p:txBody>
       </p:sp>
@@ -6748,6 +6813,7 @@
           <a:lstStyle/>
           <a:p>
             <a:pPr algn="ctr"/>
+            <a:endParaRPr/>
           </a:p>
         </p:txBody>
       </p:sp>
@@ -6915,6 +6981,7 @@
           <a:lstStyle/>
           <a:p>
             <a:pPr algn="ctr"/>
+            <a:endParaRPr/>
           </a:p>
         </p:txBody>
       </p:sp>
@@ -6962,7 +7029,7 @@
 </file>
 
 <file path=ppt/slides/slide4.xml><?xml version="1.0" encoding="utf-8"?>
-<p:sld xmlns:a="http://schemas.openxmlformats.org/drawingml/2006/main" xmlns:p="http://schemas.openxmlformats.org/presentationml/2006/main" xmlns:r="http://schemas.openxmlformats.org/officeDocument/2006/relationships">
+<p:sld xmlns:a="http://schemas.openxmlformats.org/drawingml/2006/main" xmlns:r="http://schemas.openxmlformats.org/officeDocument/2006/relationships" xmlns:p="http://schemas.openxmlformats.org/presentationml/2006/main">
   <p:cSld>
     <p:bg>
       <p:bgPr>
@@ -6978,7 +7045,14 @@
         <p:cNvGrpSpPr/>
         <p:nvPr/>
       </p:nvGrpSpPr>
-      <p:grpSpPr/>
+      <p:grpSpPr>
+        <a:xfrm>
+          <a:off x="0" y="0"/>
+          <a:ext cx="0" cy="0"/>
+          <a:chOff x="0" y="0"/>
+          <a:chExt cx="0" cy="0"/>
+        </a:xfrm>
+      </p:grpSpPr>
       <p:sp>
         <p:nvSpPr>
           <p:cNvPr id="2" name="TextBox 1"/>
@@ -7089,6 +7163,7 @@
           <a:lstStyle/>
           <a:p>
             <a:pPr algn="ctr"/>
+            <a:endParaRPr/>
           </a:p>
         </p:txBody>
       </p:sp>
@@ -7162,7 +7237,7 @@
           </a:fontRef>
         </p:style>
         <p:txBody>
-          <a:bodyPr rtlCol="0" anchor="ctr" lIns="109728" rIns="109728" tIns="73152"/>
+          <a:bodyPr lIns="109728" tIns="73152" rIns="109728" rtlCol="0" anchor="ctr"/>
           <a:lstStyle/>
           <a:p>
             <a:pPr algn="ctr"/>
@@ -7311,6 +7386,7 @@
           <a:lstStyle/>
           <a:p>
             <a:pPr algn="ctr"/>
+            <a:endParaRPr/>
           </a:p>
         </p:txBody>
       </p:sp>
@@ -7441,6 +7517,7 @@
           <a:lstStyle/>
           <a:p>
             <a:pPr algn="ctr"/>
+            <a:endParaRPr/>
           </a:p>
         </p:txBody>
       </p:sp>
@@ -7537,6 +7614,7 @@
           <a:lstStyle/>
           <a:p>
             <a:pPr algn="ctr"/>
+            <a:endParaRPr/>
           </a:p>
         </p:txBody>
       </p:sp>
@@ -7633,6 +7711,7 @@
           <a:lstStyle/>
           <a:p>
             <a:pPr algn="ctr"/>
+            <a:endParaRPr/>
           </a:p>
         </p:txBody>
       </p:sp>
@@ -7800,6 +7879,7 @@
           <a:lstStyle/>
           <a:p>
             <a:pPr algn="ctr"/>
+            <a:endParaRPr/>
           </a:p>
         </p:txBody>
       </p:sp>
@@ -7847,7 +7927,7 @@
 </file>
 
 <file path=ppt/slides/slide5.xml><?xml version="1.0" encoding="utf-8"?>
-<p:sld xmlns:a="http://schemas.openxmlformats.org/drawingml/2006/main" xmlns:p="http://schemas.openxmlformats.org/presentationml/2006/main" xmlns:r="http://schemas.openxmlformats.org/officeDocument/2006/relationships">
+<p:sld xmlns:a="http://schemas.openxmlformats.org/drawingml/2006/main" xmlns:r="http://schemas.openxmlformats.org/officeDocument/2006/relationships" xmlns:p="http://schemas.openxmlformats.org/presentationml/2006/main">
   <p:cSld>
     <p:bg>
       <p:bgPr>
@@ -7863,7 +7943,14 @@
         <p:cNvGrpSpPr/>
         <p:nvPr/>
       </p:nvGrpSpPr>
-      <p:grpSpPr/>
+      <p:grpSpPr>
+        <a:xfrm>
+          <a:off x="0" y="0"/>
+          <a:ext cx="0" cy="0"/>
+          <a:chOff x="0" y="0"/>
+          <a:chExt cx="0" cy="0"/>
+        </a:xfrm>
+      </p:grpSpPr>
       <p:sp>
         <p:nvSpPr>
           <p:cNvPr id="2" name="TextBox 1"/>
@@ -8025,6 +8112,7 @@
           <a:lstStyle/>
           <a:p>
             <a:pPr algn="ctr"/>
+            <a:endParaRPr/>
           </a:p>
         </p:txBody>
       </p:sp>
@@ -8121,6 +8209,7 @@
           <a:lstStyle/>
           <a:p>
             <a:pPr algn="ctr"/>
+            <a:endParaRPr/>
           </a:p>
         </p:txBody>
       </p:sp>
@@ -8217,6 +8306,7 @@
           <a:lstStyle/>
           <a:p>
             <a:pPr algn="ctr"/>
+            <a:endParaRPr/>
           </a:p>
         </p:txBody>
       </p:sp>
@@ -8313,6 +8403,7 @@
           <a:lstStyle/>
           <a:p>
             <a:pPr algn="ctr"/>
+            <a:endParaRPr/>
           </a:p>
         </p:txBody>
       </p:sp>
@@ -8409,6 +8500,7 @@
           <a:lstStyle/>
           <a:p>
             <a:pPr algn="ctr"/>
+            <a:endParaRPr/>
           </a:p>
         </p:txBody>
       </p:sp>
@@ -8505,6 +8597,7 @@
           <a:lstStyle/>
           <a:p>
             <a:pPr algn="ctr"/>
+            <a:endParaRPr/>
           </a:p>
         </p:txBody>
       </p:sp>
@@ -8603,6 +8696,7 @@
           <a:lstStyle/>
           <a:p>
             <a:pPr algn="ctr"/>
+            <a:endParaRPr/>
           </a:p>
         </p:txBody>
       </p:sp>
@@ -8763,7 +8857,7 @@
           </a:fontRef>
         </p:style>
         <p:txBody>
-          <a:bodyPr rtlCol="0" anchor="ctr" lIns="109728" rIns="109728" tIns="73152"/>
+          <a:bodyPr lIns="109728" tIns="73152" rIns="109728" rtlCol="0" anchor="ctr"/>
           <a:lstStyle/>
           <a:p>
             <a:pPr algn="ctr"/>
@@ -8822,6 +8916,7 @@
           <a:lstStyle/>
           <a:p>
             <a:pPr algn="ctr"/>
+            <a:endParaRPr/>
           </a:p>
         </p:txBody>
       </p:sp>
@@ -8869,7 +8964,7 @@
 </file>
 
 <file path=ppt/slides/slide6.xml><?xml version="1.0" encoding="utf-8"?>
-<p:sld xmlns:a="http://schemas.openxmlformats.org/drawingml/2006/main" xmlns:p="http://schemas.openxmlformats.org/presentationml/2006/main" xmlns:r="http://schemas.openxmlformats.org/officeDocument/2006/relationships">
+<p:sld xmlns:a="http://schemas.openxmlformats.org/drawingml/2006/main" xmlns:r="http://schemas.openxmlformats.org/officeDocument/2006/relationships" xmlns:p="http://schemas.openxmlformats.org/presentationml/2006/main">
   <p:cSld>
     <p:bg>
       <p:bgPr>
@@ -8885,7 +8980,14 @@
         <p:cNvGrpSpPr/>
         <p:nvPr/>
       </p:nvGrpSpPr>
-      <p:grpSpPr/>
+      <p:grpSpPr>
+        <a:xfrm>
+          <a:off x="0" y="0"/>
+          <a:ext cx="0" cy="0"/>
+          <a:chOff x="0" y="0"/>
+          <a:chExt cx="0" cy="0"/>
+        </a:xfrm>
+      </p:grpSpPr>
       <p:sp>
         <p:nvSpPr>
           <p:cNvPr id="2" name="TextBox 1"/>
@@ -8996,6 +9098,7 @@
           <a:lstStyle/>
           <a:p>
             <a:pPr algn="ctr"/>
+            <a:endParaRPr/>
           </a:p>
         </p:txBody>
       </p:sp>
@@ -9194,6 +9297,7 @@
           <a:lstStyle/>
           <a:p>
             <a:pPr algn="ctr"/>
+            <a:endParaRPr/>
           </a:p>
         </p:txBody>
       </p:sp>
@@ -9354,7 +9458,7 @@
           </a:fontRef>
         </p:style>
         <p:txBody>
-          <a:bodyPr rtlCol="0" anchor="ctr" lIns="109728" rIns="109728" tIns="73152"/>
+          <a:bodyPr lIns="109728" tIns="73152" rIns="109728" rtlCol="0" anchor="ctr"/>
           <a:lstStyle/>
           <a:p>
             <a:pPr algn="ctr"/>
@@ -9412,6 +9516,7 @@
           <a:lstStyle/>
           <a:p>
             <a:pPr algn="ctr"/>
+            <a:endParaRPr/>
           </a:p>
         </p:txBody>
       </p:sp>
@@ -9459,7 +9564,7 @@
 </file>
 
 <file path=ppt/slides/slide7.xml><?xml version="1.0" encoding="utf-8"?>
-<p:sld xmlns:a="http://schemas.openxmlformats.org/drawingml/2006/main" xmlns:p="http://schemas.openxmlformats.org/presentationml/2006/main" xmlns:r="http://schemas.openxmlformats.org/officeDocument/2006/relationships">
+<p:sld xmlns:a="http://schemas.openxmlformats.org/drawingml/2006/main" xmlns:r="http://schemas.openxmlformats.org/officeDocument/2006/relationships" xmlns:p="http://schemas.openxmlformats.org/presentationml/2006/main">
   <p:cSld>
     <p:bg>
       <p:bgPr>
@@ -9475,7 +9580,14 @@
         <p:cNvGrpSpPr/>
         <p:nvPr/>
       </p:nvGrpSpPr>
-      <p:grpSpPr/>
+      <p:grpSpPr>
+        <a:xfrm>
+          <a:off x="0" y="0"/>
+          <a:ext cx="0" cy="0"/>
+          <a:chOff x="0" y="0"/>
+          <a:chExt cx="0" cy="0"/>
+        </a:xfrm>
+      </p:grpSpPr>
       <p:sp>
         <p:nvSpPr>
           <p:cNvPr id="2" name="TextBox 1"/>
@@ -9586,6 +9698,7 @@
           <a:lstStyle/>
           <a:p>
             <a:pPr algn="ctr"/>
+            <a:endParaRPr/>
           </a:p>
         </p:txBody>
       </p:sp>
@@ -9746,7 +9859,7 @@
           </a:fontRef>
         </p:style>
         <p:txBody>
-          <a:bodyPr rtlCol="0" anchor="ctr" lIns="109728" rIns="109728" tIns="73152"/>
+          <a:bodyPr lIns="109728" tIns="73152" rIns="109728" rtlCol="0" anchor="ctr"/>
           <a:lstStyle/>
           <a:p>
             <a:pPr algn="ctr"/>
@@ -9804,6 +9917,7 @@
           <a:lstStyle/>
           <a:p>
             <a:pPr algn="ctr"/>
+            <a:endParaRPr/>
           </a:p>
         </p:txBody>
       </p:sp>
@@ -9968,6 +10082,7 @@
           <a:lstStyle/>
           <a:p>
             <a:pPr algn="ctr"/>
+            <a:endParaRPr/>
           </a:p>
         </p:txBody>
       </p:sp>
@@ -10015,7 +10130,7 @@
 </file>
 
 <file path=ppt/slides/slide8.xml><?xml version="1.0" encoding="utf-8"?>
-<p:sld xmlns:a="http://schemas.openxmlformats.org/drawingml/2006/main" xmlns:p="http://schemas.openxmlformats.org/presentationml/2006/main" xmlns:r="http://schemas.openxmlformats.org/officeDocument/2006/relationships">
+<p:sld xmlns:a="http://schemas.openxmlformats.org/drawingml/2006/main" xmlns:r="http://schemas.openxmlformats.org/officeDocument/2006/relationships" xmlns:p="http://schemas.openxmlformats.org/presentationml/2006/main">
   <p:cSld>
     <p:bg>
       <p:bgPr>
@@ -10031,7 +10146,14 @@
         <p:cNvGrpSpPr/>
         <p:nvPr/>
       </p:nvGrpSpPr>
-      <p:grpSpPr/>
+      <p:grpSpPr>
+        <a:xfrm>
+          <a:off x="0" y="0"/>
+          <a:ext cx="0" cy="0"/>
+          <a:chOff x="0" y="0"/>
+          <a:chExt cx="0" cy="0"/>
+        </a:xfrm>
+      </p:grpSpPr>
       <p:sp>
         <p:nvSpPr>
           <p:cNvPr id="2" name="TextBox 1"/>
@@ -10193,6 +10315,7 @@
           <a:lstStyle/>
           <a:p>
             <a:pPr algn="ctr"/>
+            <a:endParaRPr/>
           </a:p>
         </p:txBody>
       </p:sp>
@@ -10288,6 +10411,7 @@
           <a:lstStyle/>
           <a:p>
             <a:pPr algn="ctr"/>
+            <a:endParaRPr/>
           </a:p>
         </p:txBody>
       </p:sp>
@@ -10383,6 +10507,7 @@
           <a:lstStyle/>
           <a:p>
             <a:pPr algn="ctr"/>
+            <a:endParaRPr/>
           </a:p>
         </p:txBody>
       </p:sp>
@@ -10478,6 +10603,7 @@
           <a:lstStyle/>
           <a:p>
             <a:pPr algn="ctr"/>
+            <a:endParaRPr/>
           </a:p>
         </p:txBody>
       </p:sp>
@@ -10576,6 +10702,7 @@
           <a:lstStyle/>
           <a:p>
             <a:pPr algn="ctr"/>
+            <a:endParaRPr/>
           </a:p>
         </p:txBody>
       </p:sp>
@@ -10736,7 +10863,7 @@
           </a:fontRef>
         </p:style>
         <p:txBody>
-          <a:bodyPr rtlCol="0" anchor="ctr" lIns="109728" rIns="109728" tIns="73152"/>
+          <a:bodyPr lIns="109728" tIns="73152" rIns="109728" rtlCol="0" anchor="ctr"/>
           <a:lstStyle/>
           <a:p>
             <a:pPr algn="ctr"/>
@@ -10794,6 +10921,7 @@
           <a:lstStyle/>
           <a:p>
             <a:pPr algn="ctr"/>
+            <a:endParaRPr/>
           </a:p>
         </p:txBody>
       </p:sp>
@@ -10841,7 +10969,7 @@
 </file>
 
 <file path=ppt/slides/slide9.xml><?xml version="1.0" encoding="utf-8"?>
-<p:sld xmlns:a="http://schemas.openxmlformats.org/drawingml/2006/main" xmlns:p="http://schemas.openxmlformats.org/presentationml/2006/main" xmlns:r="http://schemas.openxmlformats.org/officeDocument/2006/relationships">
+<p:sld xmlns:a="http://schemas.openxmlformats.org/drawingml/2006/main" xmlns:r="http://schemas.openxmlformats.org/officeDocument/2006/relationships" xmlns:p="http://schemas.openxmlformats.org/presentationml/2006/main">
   <p:cSld>
     <p:bg>
       <p:bgPr>
@@ -10857,7 +10985,14 @@
         <p:cNvGrpSpPr/>
         <p:nvPr/>
       </p:nvGrpSpPr>
-      <p:grpSpPr/>
+      <p:grpSpPr>
+        <a:xfrm>
+          <a:off x="0" y="0"/>
+          <a:ext cx="0" cy="0"/>
+          <a:chOff x="0" y="0"/>
+          <a:chExt cx="0" cy="0"/>
+        </a:xfrm>
+      </p:grpSpPr>
       <p:sp>
         <p:nvSpPr>
           <p:cNvPr id="2" name="TextBox 1"/>
@@ -10945,11 +11080,41 @@
                 <a:tableStyleId>{5C22544A-7EE6-4342-B048-85BDC9FD1C3A}</a:tableStyleId>
               </a:tblPr>
               <a:tblGrid>
-                <a:gridCol w="1280160"/>
-                <a:gridCol w="1280160"/>
-                <a:gridCol w="1280160"/>
-                <a:gridCol w="1280160"/>
-                <a:gridCol w="1280160"/>
+                <a:gridCol w="1280160">
+                  <a:extLst>
+                    <a:ext uri="{9D8B030D-6E8A-4147-A177-3AD203B41FA5}">
+                      <a16:colId xmlns:a16="http://schemas.microsoft.com/office/drawing/2014/main" val="20000"/>
+                    </a:ext>
+                  </a:extLst>
+                </a:gridCol>
+                <a:gridCol w="1280160">
+                  <a:extLst>
+                    <a:ext uri="{9D8B030D-6E8A-4147-A177-3AD203B41FA5}">
+                      <a16:colId xmlns:a16="http://schemas.microsoft.com/office/drawing/2014/main" val="20001"/>
+                    </a:ext>
+                  </a:extLst>
+                </a:gridCol>
+                <a:gridCol w="1280160">
+                  <a:extLst>
+                    <a:ext uri="{9D8B030D-6E8A-4147-A177-3AD203B41FA5}">
+                      <a16:colId xmlns:a16="http://schemas.microsoft.com/office/drawing/2014/main" val="20002"/>
+                    </a:ext>
+                  </a:extLst>
+                </a:gridCol>
+                <a:gridCol w="1280160">
+                  <a:extLst>
+                    <a:ext uri="{9D8B030D-6E8A-4147-A177-3AD203B41FA5}">
+                      <a16:colId xmlns:a16="http://schemas.microsoft.com/office/drawing/2014/main" val="20003"/>
+                    </a:ext>
+                  </a:extLst>
+                </a:gridCol>
+                <a:gridCol w="1280160">
+                  <a:extLst>
+                    <a:ext uri="{9D8B030D-6E8A-4147-A177-3AD203B41FA5}">
+                      <a16:colId xmlns:a16="http://schemas.microsoft.com/office/drawing/2014/main" val="20004"/>
+                    </a:ext>
+                  </a:extLst>
+                </a:gridCol>
               </a:tblGrid>
               <a:tr h="411480">
                 <a:tc>
@@ -10958,7 +11123,7 @@
                     <a:lstStyle/>
                     <a:p>
                       <a:pPr>
-                        <a:defRPr b="1" sz="1000"/>
+                        <a:defRPr sz="1000" b="1"/>
                       </a:pPr>
                       <a:r>
                         <a:t>数据</a:t>
@@ -10977,7 +11142,7 @@
                     <a:lstStyle/>
                     <a:p>
                       <a:pPr>
-                        <a:defRPr b="1" sz="1000"/>
+                        <a:defRPr sz="1000" b="1"/>
                       </a:pPr>
                       <a:r>
                         <a:t>Acc</a:t>
@@ -10996,7 +11161,7 @@
                     <a:lstStyle/>
                     <a:p>
                       <a:pPr>
-                        <a:defRPr b="1" sz="1000"/>
+                        <a:defRPr sz="1000" b="1"/>
                       </a:pPr>
                       <a:r>
                         <a:t>Precision</a:t>
@@ -11015,7 +11180,7 @@
                     <a:lstStyle/>
                     <a:p>
                       <a:pPr>
-                        <a:defRPr b="1" sz="1000"/>
+                        <a:defRPr sz="1000" b="1"/>
                       </a:pPr>
                       <a:r>
                         <a:t>Recall</a:t>
@@ -11034,7 +11199,7 @@
                     <a:lstStyle/>
                     <a:p>
                       <a:pPr>
-                        <a:defRPr b="1" sz="1000"/>
+                        <a:defRPr sz="1000" b="1"/>
                       </a:pPr>
                       <a:r>
                         <a:t>F1</a:t>
@@ -11047,6 +11212,11 @@
                     </a:solidFill>
                   </a:tcPr>
                 </a:tc>
+                <a:extLst>
+                  <a:ext uri="{0D108BD9-81ED-4DB2-BD59-A6C34878D82A}">
+                    <a16:rowId xmlns:a16="http://schemas.microsoft.com/office/drawing/2014/main" val="10000"/>
+                  </a:ext>
+                </a:extLst>
               </a:tr>
               <a:tr h="411480">
                 <a:tc>
@@ -11124,6 +11294,11 @@
                   </a:txBody>
                   <a:tcPr/>
                 </a:tc>
+                <a:extLst>
+                  <a:ext uri="{0D108BD9-81ED-4DB2-BD59-A6C34878D82A}">
+                    <a16:rowId xmlns:a16="http://schemas.microsoft.com/office/drawing/2014/main" val="10001"/>
+                  </a:ext>
+                </a:extLst>
               </a:tr>
               <a:tr h="411480">
                 <a:tc>
@@ -11201,6 +11376,11 @@
                   </a:txBody>
                   <a:tcPr/>
                 </a:tc>
+                <a:extLst>
+                  <a:ext uri="{0D108BD9-81ED-4DB2-BD59-A6C34878D82A}">
+                    <a16:rowId xmlns:a16="http://schemas.microsoft.com/office/drawing/2014/main" val="10002"/>
+                  </a:ext>
+                </a:extLst>
               </a:tr>
               <a:tr h="411480">
                 <a:tc>
@@ -11278,6 +11458,11 @@
                   </a:txBody>
                   <a:tcPr/>
                 </a:tc>
+                <a:extLst>
+                  <a:ext uri="{0D108BD9-81ED-4DB2-BD59-A6C34878D82A}">
+                    <a16:rowId xmlns:a16="http://schemas.microsoft.com/office/drawing/2014/main" val="10003"/>
+                  </a:ext>
+                </a:extLst>
               </a:tr>
             </a:tbl>
           </a:graphicData>
@@ -11325,6 +11510,7 @@
           <a:lstStyle/>
           <a:p>
             <a:pPr algn="ctr"/>
+            <a:endParaRPr/>
           </a:p>
         </p:txBody>
       </p:sp>
@@ -11491,6 +11677,7 @@
           <a:lstStyle/>
           <a:p>
             <a:pPr algn="ctr"/>
+            <a:endParaRPr/>
           </a:p>
         </p:txBody>
       </p:sp>
@@ -11655,6 +11842,7 @@
           <a:lstStyle/>
           <a:p>
             <a:pPr algn="ctr"/>
+            <a:endParaRPr/>
           </a:p>
         </p:txBody>
       </p:sp>

</xml_diff>

<commit_message>
Clean submission dependencies and package notes
</commit_message>
<xml_diff>
--- a/docs/智能驾驶车道二分类PPT设计文档.pptx
+++ b/docs/智能驾驶车道二分类PPT设计文档.pptx
@@ -5,22 +5,22 @@
     <p:sldMasterId id="2147483648" r:id="rId1"/>
   </p:sldMasterIdLst>
   <p:sldIdLst>
-    <p:sldId id="256" r:id="rId7"/>
-    <p:sldId id="257" r:id="rId8"/>
-    <p:sldId id="258" r:id="rId9"/>
-    <p:sldId id="259" r:id="rId10"/>
-    <p:sldId id="260" r:id="rId11"/>
-    <p:sldId id="261" r:id="rId12"/>
-    <p:sldId id="262" r:id="rId13"/>
-    <p:sldId id="263" r:id="rId14"/>
-    <p:sldId id="264" r:id="rId15"/>
-    <p:sldId id="265" r:id="rId16"/>
-    <p:sldId id="266" r:id="rId17"/>
-    <p:sldId id="267" r:id="rId18"/>
-    <p:sldId id="268" r:id="rId19"/>
-    <p:sldId id="269" r:id="rId20"/>
+    <p:sldId id="256" r:id="rId2"/>
+    <p:sldId id="257" r:id="rId3"/>
+    <p:sldId id="258" r:id="rId4"/>
+    <p:sldId id="259" r:id="rId5"/>
+    <p:sldId id="260" r:id="rId6"/>
+    <p:sldId id="261" r:id="rId7"/>
+    <p:sldId id="262" r:id="rId8"/>
+    <p:sldId id="263" r:id="rId9"/>
+    <p:sldId id="264" r:id="rId10"/>
+    <p:sldId id="265" r:id="rId11"/>
+    <p:sldId id="266" r:id="rId12"/>
+    <p:sldId id="267" r:id="rId13"/>
+    <p:sldId id="268" r:id="rId14"/>
+    <p:sldId id="269" r:id="rId15"/>
   </p:sldIdLst>
-  <p:sldSz cx="12191695" cy="6858000" type="screen4x3"/>
+  <p:sldSz cx="12192000" cy="6858000"/>
   <p:notesSz cx="6858000" cy="9144000"/>
   <p:defaultTextStyle>
     <a:defPPr>
@@ -117,6 +117,22 @@
       </a:defRPr>
     </a:lvl9pPr>
   </p:defaultTextStyle>
+  <p:extLst>
+    <p:ext uri="{EFAFB233-063F-42B5-8137-9DF3F51BA10A}">
+      <p15:sldGuideLst xmlns:p15="http://schemas.microsoft.com/office/powerpoint/2012/main">
+        <p15:guide id="1" orient="horz" pos="2160">
+          <p15:clr>
+            <a:srgbClr val="A4A3A4"/>
+          </p15:clr>
+        </p15:guide>
+        <p15:guide id="2" pos="2880">
+          <p15:clr>
+            <a:srgbClr val="A4A3A4"/>
+          </p15:clr>
+        </p15:guide>
+      </p15:sldGuideLst>
+    </p:ext>
+  </p:extLst>
 </p:presentation>
 </file>
 
@@ -158,10 +174,9 @@
           <a:lstStyle/>
           <a:p>
             <a:r>
-              <a:rPr lang="en-US" smtClean="0"/>
+              <a:rPr lang="en-US"/>
               <a:t>Click to edit Master title style</a:t>
             </a:r>
-            <a:endParaRPr lang="en-US"/>
           </a:p>
         </p:txBody>
       </p:sp>
@@ -277,10 +292,9 @@
           </a:lstStyle>
           <a:p>
             <a:r>
-              <a:rPr lang="en-US" smtClean="0"/>
+              <a:rPr lang="en-US"/>
               <a:t>Click to edit Master subtitle style</a:t>
             </a:r>
-            <a:endParaRPr lang="en-US"/>
           </a:p>
         </p:txBody>
       </p:sp>
@@ -301,7 +315,7 @@
           <a:p>
             <a:fld id="{5BCAD085-E8A6-8845-BD4E-CB4CCA059FC4}" type="datetimeFigureOut">
               <a:rPr lang="en-US" smtClean="0"/>
-              <a:t>1/27/13</a:t>
+              <a:t>6/28/2026</a:t>
             </a:fld>
             <a:endParaRPr lang="en-US"/>
           </a:p>
@@ -395,10 +409,9 @@
           <a:lstStyle/>
           <a:p>
             <a:r>
-              <a:rPr lang="en-US" smtClean="0"/>
+              <a:rPr lang="en-US"/>
               <a:t>Click to edit Master title style</a:t>
             </a:r>
-            <a:endParaRPr lang="en-US"/>
           </a:p>
         </p:txBody>
       </p:sp>
@@ -419,38 +432,37 @@
           <a:p>
             <a:pPr lvl="0"/>
             <a:r>
-              <a:rPr lang="en-US" smtClean="0"/>
+              <a:rPr lang="en-US"/>
               <a:t>Click to edit Master text styles</a:t>
             </a:r>
           </a:p>
           <a:p>
             <a:pPr lvl="1"/>
             <a:r>
-              <a:rPr lang="en-US" smtClean="0"/>
+              <a:rPr lang="en-US"/>
               <a:t>Second level</a:t>
             </a:r>
           </a:p>
           <a:p>
             <a:pPr lvl="2"/>
             <a:r>
-              <a:rPr lang="en-US" smtClean="0"/>
+              <a:rPr lang="en-US"/>
               <a:t>Third level</a:t>
             </a:r>
           </a:p>
           <a:p>
             <a:pPr lvl="3"/>
             <a:r>
-              <a:rPr lang="en-US" smtClean="0"/>
+              <a:rPr lang="en-US"/>
               <a:t>Fourth level</a:t>
             </a:r>
           </a:p>
           <a:p>
             <a:pPr lvl="4"/>
             <a:r>
-              <a:rPr lang="en-US" smtClean="0"/>
+              <a:rPr lang="en-US"/>
               <a:t>Fifth level</a:t>
             </a:r>
-            <a:endParaRPr lang="en-US"/>
           </a:p>
         </p:txBody>
       </p:sp>
@@ -471,7 +483,7 @@
           <a:p>
             <a:fld id="{5BCAD085-E8A6-8845-BD4E-CB4CCA059FC4}" type="datetimeFigureOut">
               <a:rPr lang="en-US" smtClean="0"/>
-              <a:t>1/27/13</a:t>
+              <a:t>6/28/2026</a:t>
             </a:fld>
             <a:endParaRPr lang="en-US"/>
           </a:p>
@@ -570,10 +582,9 @@
           <a:lstStyle/>
           <a:p>
             <a:r>
-              <a:rPr lang="en-US" smtClean="0"/>
+              <a:rPr lang="en-US"/>
               <a:t>Click to edit Master title style</a:t>
             </a:r>
-            <a:endParaRPr lang="en-US"/>
           </a:p>
         </p:txBody>
       </p:sp>
@@ -599,38 +610,37 @@
           <a:p>
             <a:pPr lvl="0"/>
             <a:r>
-              <a:rPr lang="en-US" smtClean="0"/>
+              <a:rPr lang="en-US"/>
               <a:t>Click to edit Master text styles</a:t>
             </a:r>
           </a:p>
           <a:p>
             <a:pPr lvl="1"/>
             <a:r>
-              <a:rPr lang="en-US" smtClean="0"/>
+              <a:rPr lang="en-US"/>
               <a:t>Second level</a:t>
             </a:r>
           </a:p>
           <a:p>
             <a:pPr lvl="2"/>
             <a:r>
-              <a:rPr lang="en-US" smtClean="0"/>
+              <a:rPr lang="en-US"/>
               <a:t>Third level</a:t>
             </a:r>
           </a:p>
           <a:p>
             <a:pPr lvl="3"/>
             <a:r>
-              <a:rPr lang="en-US" smtClean="0"/>
+              <a:rPr lang="en-US"/>
               <a:t>Fourth level</a:t>
             </a:r>
           </a:p>
           <a:p>
             <a:pPr lvl="4"/>
             <a:r>
-              <a:rPr lang="en-US" smtClean="0"/>
+              <a:rPr lang="en-US"/>
               <a:t>Fifth level</a:t>
             </a:r>
-            <a:endParaRPr lang="en-US"/>
           </a:p>
         </p:txBody>
       </p:sp>
@@ -651,7 +661,7 @@
           <a:p>
             <a:fld id="{5BCAD085-E8A6-8845-BD4E-CB4CCA059FC4}" type="datetimeFigureOut">
               <a:rPr lang="en-US" smtClean="0"/>
-              <a:t>1/27/13</a:t>
+              <a:t>6/28/2026</a:t>
             </a:fld>
             <a:endParaRPr lang="en-US"/>
           </a:p>
@@ -745,10 +755,9 @@
           <a:lstStyle/>
           <a:p>
             <a:r>
-              <a:rPr lang="en-US" smtClean="0"/>
+              <a:rPr lang="en-US"/>
               <a:t>Click to edit Master title style</a:t>
             </a:r>
-            <a:endParaRPr lang="en-US"/>
           </a:p>
         </p:txBody>
       </p:sp>
@@ -769,38 +778,37 @@
           <a:p>
             <a:pPr lvl="0"/>
             <a:r>
-              <a:rPr lang="en-US" smtClean="0"/>
+              <a:rPr lang="en-US"/>
               <a:t>Click to edit Master text styles</a:t>
             </a:r>
           </a:p>
           <a:p>
             <a:pPr lvl="1"/>
             <a:r>
-              <a:rPr lang="en-US" smtClean="0"/>
+              <a:rPr lang="en-US"/>
               <a:t>Second level</a:t>
             </a:r>
           </a:p>
           <a:p>
             <a:pPr lvl="2"/>
             <a:r>
-              <a:rPr lang="en-US" smtClean="0"/>
+              <a:rPr lang="en-US"/>
               <a:t>Third level</a:t>
             </a:r>
           </a:p>
           <a:p>
             <a:pPr lvl="3"/>
             <a:r>
-              <a:rPr lang="en-US" smtClean="0"/>
+              <a:rPr lang="en-US"/>
               <a:t>Fourth level</a:t>
             </a:r>
           </a:p>
           <a:p>
             <a:pPr lvl="4"/>
             <a:r>
-              <a:rPr lang="en-US" smtClean="0"/>
+              <a:rPr lang="en-US"/>
               <a:t>Fifth level</a:t>
             </a:r>
-            <a:endParaRPr lang="en-US"/>
           </a:p>
         </p:txBody>
       </p:sp>
@@ -821,7 +829,7 @@
           <a:p>
             <a:fld id="{5BCAD085-E8A6-8845-BD4E-CB4CCA059FC4}" type="datetimeFigureOut">
               <a:rPr lang="en-US" smtClean="0"/>
-              <a:t>1/27/13</a:t>
+              <a:t>6/28/2026</a:t>
             </a:fld>
             <a:endParaRPr lang="en-US"/>
           </a:p>
@@ -924,10 +932,9 @@
           </a:lstStyle>
           <a:p>
             <a:r>
-              <a:rPr lang="en-US" smtClean="0"/>
+              <a:rPr lang="en-US"/>
               <a:t>Click to edit Master title style</a:t>
             </a:r>
-            <a:endParaRPr lang="en-US"/>
           </a:p>
         </p:txBody>
       </p:sp>
@@ -1044,7 +1051,7 @@
           <a:p>
             <a:pPr lvl="0"/>
             <a:r>
-              <a:rPr lang="en-US" smtClean="0"/>
+              <a:rPr lang="en-US"/>
               <a:t>Click to edit Master text styles</a:t>
             </a:r>
           </a:p>
@@ -1067,7 +1074,7 @@
           <a:p>
             <a:fld id="{5BCAD085-E8A6-8845-BD4E-CB4CCA059FC4}" type="datetimeFigureOut">
               <a:rPr lang="en-US" smtClean="0"/>
-              <a:t>1/27/13</a:t>
+              <a:t>6/28/2026</a:t>
             </a:fld>
             <a:endParaRPr lang="en-US"/>
           </a:p>
@@ -1161,10 +1168,9 @@
           <a:lstStyle/>
           <a:p>
             <a:r>
-              <a:rPr lang="en-US" smtClean="0"/>
+              <a:rPr lang="en-US"/>
               <a:t>Click to edit Master title style</a:t>
             </a:r>
-            <a:endParaRPr lang="en-US"/>
           </a:p>
         </p:txBody>
       </p:sp>
@@ -1218,38 +1224,37 @@
           <a:p>
             <a:pPr lvl="0"/>
             <a:r>
-              <a:rPr lang="en-US" smtClean="0"/>
+              <a:rPr lang="en-US"/>
               <a:t>Click to edit Master text styles</a:t>
             </a:r>
           </a:p>
           <a:p>
             <a:pPr lvl="1"/>
             <a:r>
-              <a:rPr lang="en-US" smtClean="0"/>
+              <a:rPr lang="en-US"/>
               <a:t>Second level</a:t>
             </a:r>
           </a:p>
           <a:p>
             <a:pPr lvl="2"/>
             <a:r>
-              <a:rPr lang="en-US" smtClean="0"/>
+              <a:rPr lang="en-US"/>
               <a:t>Third level</a:t>
             </a:r>
           </a:p>
           <a:p>
             <a:pPr lvl="3"/>
             <a:r>
-              <a:rPr lang="en-US" smtClean="0"/>
+              <a:rPr lang="en-US"/>
               <a:t>Fourth level</a:t>
             </a:r>
           </a:p>
           <a:p>
             <a:pPr lvl="4"/>
             <a:r>
-              <a:rPr lang="en-US" smtClean="0"/>
+              <a:rPr lang="en-US"/>
               <a:t>Fifth level</a:t>
             </a:r>
-            <a:endParaRPr lang="en-US"/>
           </a:p>
         </p:txBody>
       </p:sp>
@@ -1303,38 +1308,37 @@
           <a:p>
             <a:pPr lvl="0"/>
             <a:r>
-              <a:rPr lang="en-US" smtClean="0"/>
+              <a:rPr lang="en-US"/>
               <a:t>Click to edit Master text styles</a:t>
             </a:r>
           </a:p>
           <a:p>
             <a:pPr lvl="1"/>
             <a:r>
-              <a:rPr lang="en-US" smtClean="0"/>
+              <a:rPr lang="en-US"/>
               <a:t>Second level</a:t>
             </a:r>
           </a:p>
           <a:p>
             <a:pPr lvl="2"/>
             <a:r>
-              <a:rPr lang="en-US" smtClean="0"/>
+              <a:rPr lang="en-US"/>
               <a:t>Third level</a:t>
             </a:r>
           </a:p>
           <a:p>
             <a:pPr lvl="3"/>
             <a:r>
-              <a:rPr lang="en-US" smtClean="0"/>
+              <a:rPr lang="en-US"/>
               <a:t>Fourth level</a:t>
             </a:r>
           </a:p>
           <a:p>
             <a:pPr lvl="4"/>
             <a:r>
-              <a:rPr lang="en-US" smtClean="0"/>
+              <a:rPr lang="en-US"/>
               <a:t>Fifth level</a:t>
             </a:r>
-            <a:endParaRPr lang="en-US"/>
           </a:p>
         </p:txBody>
       </p:sp>
@@ -1355,7 +1359,7 @@
           <a:p>
             <a:fld id="{5BCAD085-E8A6-8845-BD4E-CB4CCA059FC4}" type="datetimeFigureOut">
               <a:rPr lang="en-US" smtClean="0"/>
-              <a:t>1/27/13</a:t>
+              <a:t>6/28/2026</a:t>
             </a:fld>
             <a:endParaRPr lang="en-US"/>
           </a:p>
@@ -1453,10 +1457,9 @@
           </a:lstStyle>
           <a:p>
             <a:r>
-              <a:rPr lang="en-US" smtClean="0"/>
+              <a:rPr lang="en-US"/>
               <a:t>Click to edit Master title style</a:t>
             </a:r>
-            <a:endParaRPr lang="en-US"/>
           </a:p>
         </p:txBody>
       </p:sp>
@@ -1519,7 +1522,7 @@
           <a:p>
             <a:pPr lvl="0"/>
             <a:r>
-              <a:rPr lang="en-US" smtClean="0"/>
+              <a:rPr lang="en-US"/>
               <a:t>Click to edit Master text styles</a:t>
             </a:r>
           </a:p>
@@ -1575,38 +1578,37 @@
           <a:p>
             <a:pPr lvl="0"/>
             <a:r>
-              <a:rPr lang="en-US" smtClean="0"/>
+              <a:rPr lang="en-US"/>
               <a:t>Click to edit Master text styles</a:t>
             </a:r>
           </a:p>
           <a:p>
             <a:pPr lvl="1"/>
             <a:r>
-              <a:rPr lang="en-US" smtClean="0"/>
+              <a:rPr lang="en-US"/>
               <a:t>Second level</a:t>
             </a:r>
           </a:p>
           <a:p>
             <a:pPr lvl="2"/>
             <a:r>
-              <a:rPr lang="en-US" smtClean="0"/>
+              <a:rPr lang="en-US"/>
               <a:t>Third level</a:t>
             </a:r>
           </a:p>
           <a:p>
             <a:pPr lvl="3"/>
             <a:r>
-              <a:rPr lang="en-US" smtClean="0"/>
+              <a:rPr lang="en-US"/>
               <a:t>Fourth level</a:t>
             </a:r>
           </a:p>
           <a:p>
             <a:pPr lvl="4"/>
             <a:r>
-              <a:rPr lang="en-US" smtClean="0"/>
+              <a:rPr lang="en-US"/>
               <a:t>Fifth level</a:t>
             </a:r>
-            <a:endParaRPr lang="en-US"/>
           </a:p>
         </p:txBody>
       </p:sp>
@@ -1669,7 +1671,7 @@
           <a:p>
             <a:pPr lvl="0"/>
             <a:r>
-              <a:rPr lang="en-US" smtClean="0"/>
+              <a:rPr lang="en-US"/>
               <a:t>Click to edit Master text styles</a:t>
             </a:r>
           </a:p>
@@ -1725,38 +1727,37 @@
           <a:p>
             <a:pPr lvl="0"/>
             <a:r>
-              <a:rPr lang="en-US" smtClean="0"/>
+              <a:rPr lang="en-US"/>
               <a:t>Click to edit Master text styles</a:t>
             </a:r>
           </a:p>
           <a:p>
             <a:pPr lvl="1"/>
             <a:r>
-              <a:rPr lang="en-US" smtClean="0"/>
+              <a:rPr lang="en-US"/>
               <a:t>Second level</a:t>
             </a:r>
           </a:p>
           <a:p>
             <a:pPr lvl="2"/>
             <a:r>
-              <a:rPr lang="en-US" smtClean="0"/>
+              <a:rPr lang="en-US"/>
               <a:t>Third level</a:t>
             </a:r>
           </a:p>
           <a:p>
             <a:pPr lvl="3"/>
             <a:r>
-              <a:rPr lang="en-US" smtClean="0"/>
+              <a:rPr lang="en-US"/>
               <a:t>Fourth level</a:t>
             </a:r>
           </a:p>
           <a:p>
             <a:pPr lvl="4"/>
             <a:r>
-              <a:rPr lang="en-US" smtClean="0"/>
+              <a:rPr lang="en-US"/>
               <a:t>Fifth level</a:t>
             </a:r>
-            <a:endParaRPr lang="en-US"/>
           </a:p>
         </p:txBody>
       </p:sp>
@@ -1777,7 +1778,7 @@
           <a:p>
             <a:fld id="{5BCAD085-E8A6-8845-BD4E-CB4CCA059FC4}" type="datetimeFigureOut">
               <a:rPr lang="en-US" smtClean="0"/>
-              <a:t>1/27/13</a:t>
+              <a:t>6/28/2026</a:t>
             </a:fld>
             <a:endParaRPr lang="en-US"/>
           </a:p>
@@ -1871,10 +1872,9 @@
           <a:lstStyle/>
           <a:p>
             <a:r>
-              <a:rPr lang="en-US" smtClean="0"/>
+              <a:rPr lang="en-US"/>
               <a:t>Click to edit Master title style</a:t>
             </a:r>
-            <a:endParaRPr lang="en-US"/>
           </a:p>
         </p:txBody>
       </p:sp>
@@ -1895,7 +1895,7 @@
           <a:p>
             <a:fld id="{5BCAD085-E8A6-8845-BD4E-CB4CCA059FC4}" type="datetimeFigureOut">
               <a:rPr lang="en-US" smtClean="0"/>
-              <a:t>1/27/13</a:t>
+              <a:t>6/28/2026</a:t>
             </a:fld>
             <a:endParaRPr lang="en-US"/>
           </a:p>
@@ -1990,7 +1990,7 @@
           <a:p>
             <a:fld id="{5BCAD085-E8A6-8845-BD4E-CB4CCA059FC4}" type="datetimeFigureOut">
               <a:rPr lang="en-US" smtClean="0"/>
-              <a:t>1/27/13</a:t>
+              <a:t>6/28/2026</a:t>
             </a:fld>
             <a:endParaRPr lang="en-US"/>
           </a:p>
@@ -2093,10 +2093,9 @@
           </a:lstStyle>
           <a:p>
             <a:r>
-              <a:rPr lang="en-US" smtClean="0"/>
+              <a:rPr lang="en-US"/>
               <a:t>Click to edit Master title style</a:t>
             </a:r>
-            <a:endParaRPr lang="en-US"/>
           </a:p>
         </p:txBody>
       </p:sp>
@@ -2150,38 +2149,37 @@
           <a:p>
             <a:pPr lvl="0"/>
             <a:r>
-              <a:rPr lang="en-US" smtClean="0"/>
+              <a:rPr lang="en-US"/>
               <a:t>Click to edit Master text styles</a:t>
             </a:r>
           </a:p>
           <a:p>
             <a:pPr lvl="1"/>
             <a:r>
-              <a:rPr lang="en-US" smtClean="0"/>
+              <a:rPr lang="en-US"/>
               <a:t>Second level</a:t>
             </a:r>
           </a:p>
           <a:p>
             <a:pPr lvl="2"/>
             <a:r>
-              <a:rPr lang="en-US" smtClean="0"/>
+              <a:rPr lang="en-US"/>
               <a:t>Third level</a:t>
             </a:r>
           </a:p>
           <a:p>
             <a:pPr lvl="3"/>
             <a:r>
-              <a:rPr lang="en-US" smtClean="0"/>
+              <a:rPr lang="en-US"/>
               <a:t>Fourth level</a:t>
             </a:r>
           </a:p>
           <a:p>
             <a:pPr lvl="4"/>
             <a:r>
-              <a:rPr lang="en-US" smtClean="0"/>
+              <a:rPr lang="en-US"/>
               <a:t>Fifth level</a:t>
             </a:r>
-            <a:endParaRPr lang="en-US"/>
           </a:p>
         </p:txBody>
       </p:sp>
@@ -2244,7 +2242,7 @@
           <a:p>
             <a:pPr lvl="0"/>
             <a:r>
-              <a:rPr lang="en-US" smtClean="0"/>
+              <a:rPr lang="en-US"/>
               <a:t>Click to edit Master text styles</a:t>
             </a:r>
           </a:p>
@@ -2267,7 +2265,7 @@
           <a:p>
             <a:fld id="{5BCAD085-E8A6-8845-BD4E-CB4CCA059FC4}" type="datetimeFigureOut">
               <a:rPr lang="en-US" smtClean="0"/>
-              <a:t>1/27/13</a:t>
+              <a:t>6/28/2026</a:t>
             </a:fld>
             <a:endParaRPr lang="en-US"/>
           </a:p>
@@ -2370,10 +2368,9 @@
           </a:lstStyle>
           <a:p>
             <a:r>
-              <a:rPr lang="en-US" smtClean="0"/>
+              <a:rPr lang="en-US"/>
               <a:t>Click to edit Master title style</a:t>
             </a:r>
-            <a:endParaRPr lang="en-US"/>
           </a:p>
         </p:txBody>
       </p:sp>
@@ -2497,7 +2494,7 @@
           <a:p>
             <a:pPr lvl="0"/>
             <a:r>
-              <a:rPr lang="en-US" smtClean="0"/>
+              <a:rPr lang="en-US"/>
               <a:t>Click to edit Master text styles</a:t>
             </a:r>
           </a:p>
@@ -2520,7 +2517,7 @@
           <a:p>
             <a:fld id="{5BCAD085-E8A6-8845-BD4E-CB4CCA059FC4}" type="datetimeFigureOut">
               <a:rPr lang="en-US" smtClean="0"/>
-              <a:t>1/27/13</a:t>
+              <a:t>6/28/2026</a:t>
             </a:fld>
             <a:endParaRPr lang="en-US"/>
           </a:p>
@@ -2629,10 +2626,9 @@
           <a:lstStyle/>
           <a:p>
             <a:r>
-              <a:rPr lang="en-US" smtClean="0"/>
+              <a:rPr lang="en-US"/>
               <a:t>Click to edit Master title style</a:t>
             </a:r>
-            <a:endParaRPr lang="en-US"/>
           </a:p>
         </p:txBody>
       </p:sp>
@@ -2663,38 +2659,37 @@
           <a:p>
             <a:pPr lvl="0"/>
             <a:r>
-              <a:rPr lang="en-US" smtClean="0"/>
+              <a:rPr lang="en-US"/>
               <a:t>Click to edit Master text styles</a:t>
             </a:r>
           </a:p>
           <a:p>
             <a:pPr lvl="1"/>
             <a:r>
-              <a:rPr lang="en-US" smtClean="0"/>
+              <a:rPr lang="en-US"/>
               <a:t>Second level</a:t>
             </a:r>
           </a:p>
           <a:p>
             <a:pPr lvl="2"/>
             <a:r>
-              <a:rPr lang="en-US" smtClean="0"/>
+              <a:rPr lang="en-US"/>
               <a:t>Third level</a:t>
             </a:r>
           </a:p>
           <a:p>
             <a:pPr lvl="3"/>
             <a:r>
-              <a:rPr lang="en-US" smtClean="0"/>
+              <a:rPr lang="en-US"/>
               <a:t>Fourth level</a:t>
             </a:r>
           </a:p>
           <a:p>
             <a:pPr lvl="4"/>
             <a:r>
-              <a:rPr lang="en-US" smtClean="0"/>
+              <a:rPr lang="en-US"/>
               <a:t>Fifth level</a:t>
             </a:r>
-            <a:endParaRPr lang="en-US"/>
           </a:p>
         </p:txBody>
       </p:sp>
@@ -2733,7 +2728,7 @@
           <a:p>
             <a:fld id="{5BCAD085-E8A6-8845-BD4E-CB4CCA059FC4}" type="datetimeFigureOut">
               <a:rPr lang="en-US" smtClean="0"/>
-              <a:t>1/27/13</a:t>
+              <a:t>6/28/2026</a:t>
             </a:fld>
             <a:endParaRPr lang="en-US"/>
           </a:p>
@@ -3092,7 +3087,7 @@
 </file>
 
 <file path=ppt/slides/slide1.xml><?xml version="1.0" encoding="utf-8"?>
-<p:sld xmlns:a="http://schemas.openxmlformats.org/drawingml/2006/main" xmlns:p="http://schemas.openxmlformats.org/presentationml/2006/main" xmlns:r="http://schemas.openxmlformats.org/officeDocument/2006/relationships">
+<p:sld xmlns:a="http://schemas.openxmlformats.org/drawingml/2006/main" xmlns:r="http://schemas.openxmlformats.org/officeDocument/2006/relationships" xmlns:p="http://schemas.openxmlformats.org/presentationml/2006/main">
   <p:cSld>
     <p:bg>
       <p:bgPr>
@@ -3108,7 +3103,14 @@
         <p:cNvGrpSpPr/>
         <p:nvPr/>
       </p:nvGrpSpPr>
-      <p:grpSpPr/>
+      <p:grpSpPr>
+        <a:xfrm>
+          <a:off x="0" y="0"/>
+          <a:ext cx="0" cy="0"/>
+          <a:chOff x="0" y="0"/>
+          <a:chExt cx="0" cy="0"/>
+        </a:xfrm>
+      </p:grpSpPr>
       <p:sp>
         <p:nvSpPr>
           <p:cNvPr id="2" name="Rounded Rectangle 1"/>
@@ -3322,6 +3324,7 @@
           <a:lstStyle/>
           <a:p>
             <a:pPr algn="ctr"/>
+            <a:endParaRPr/>
           </a:p>
         </p:txBody>
       </p:sp>
@@ -3417,6 +3420,7 @@
           <a:lstStyle/>
           <a:p>
             <a:pPr algn="ctr"/>
+            <a:endParaRPr/>
           </a:p>
         </p:txBody>
       </p:sp>
@@ -3512,6 +3516,7 @@
           <a:lstStyle/>
           <a:p>
             <a:pPr algn="ctr"/>
+            <a:endParaRPr/>
           </a:p>
         </p:txBody>
       </p:sp>
@@ -3607,6 +3612,7 @@
           <a:lstStyle/>
           <a:p>
             <a:pPr algn="ctr"/>
+            <a:endParaRPr/>
           </a:p>
         </p:txBody>
       </p:sp>
@@ -3702,6 +3708,7 @@
           <a:lstStyle/>
           <a:p>
             <a:pPr algn="ctr"/>
+            <a:endParaRPr/>
           </a:p>
         </p:txBody>
       </p:sp>
@@ -3797,6 +3804,7 @@
           <a:lstStyle/>
           <a:p>
             <a:pPr algn="ctr"/>
+            <a:endParaRPr/>
           </a:p>
         </p:txBody>
       </p:sp>
@@ -3844,7 +3852,7 @@
 </file>
 
 <file path=ppt/slides/slide10.xml><?xml version="1.0" encoding="utf-8"?>
-<p:sld xmlns:a="http://schemas.openxmlformats.org/drawingml/2006/main" xmlns:p="http://schemas.openxmlformats.org/presentationml/2006/main" xmlns:r="http://schemas.openxmlformats.org/officeDocument/2006/relationships">
+<p:sld xmlns:a="http://schemas.openxmlformats.org/drawingml/2006/main" xmlns:r="http://schemas.openxmlformats.org/officeDocument/2006/relationships" xmlns:p="http://schemas.openxmlformats.org/presentationml/2006/main">
   <p:cSld>
     <p:bg>
       <p:bgPr>
@@ -3860,7 +3868,14 @@
         <p:cNvGrpSpPr/>
         <p:nvPr/>
       </p:nvGrpSpPr>
-      <p:grpSpPr/>
+      <p:grpSpPr>
+        <a:xfrm>
+          <a:off x="0" y="0"/>
+          <a:ext cx="0" cy="0"/>
+          <a:chOff x="0" y="0"/>
+          <a:chExt cx="0" cy="0"/>
+        </a:xfrm>
+      </p:grpSpPr>
       <p:sp>
         <p:nvSpPr>
           <p:cNvPr id="2" name="TextBox 1"/>
@@ -4048,6 +4063,7 @@
           <a:lstStyle/>
           <a:p>
             <a:pPr algn="ctr"/>
+            <a:endParaRPr/>
           </a:p>
         </p:txBody>
       </p:sp>
@@ -4095,7 +4111,7 @@
 </file>
 
 <file path=ppt/slides/slide11.xml><?xml version="1.0" encoding="utf-8"?>
-<p:sld xmlns:a="http://schemas.openxmlformats.org/drawingml/2006/main" xmlns:p="http://schemas.openxmlformats.org/presentationml/2006/main" xmlns:r="http://schemas.openxmlformats.org/officeDocument/2006/relationships">
+<p:sld xmlns:a="http://schemas.openxmlformats.org/drawingml/2006/main" xmlns:r="http://schemas.openxmlformats.org/officeDocument/2006/relationships" xmlns:p="http://schemas.openxmlformats.org/presentationml/2006/main">
   <p:cSld>
     <p:bg>
       <p:bgPr>
@@ -4111,7 +4127,14 @@
         <p:cNvGrpSpPr/>
         <p:nvPr/>
       </p:nvGrpSpPr>
-      <p:grpSpPr/>
+      <p:grpSpPr>
+        <a:xfrm>
+          <a:off x="0" y="0"/>
+          <a:ext cx="0" cy="0"/>
+          <a:chOff x="0" y="0"/>
+          <a:chExt cx="0" cy="0"/>
+        </a:xfrm>
+      </p:grpSpPr>
       <p:sp>
         <p:nvSpPr>
           <p:cNvPr id="2" name="TextBox 1"/>
@@ -4199,11 +4222,41 @@
                 <a:tableStyleId>{5C22544A-7EE6-4342-B048-85BDC9FD1C3A}</a:tableStyleId>
               </a:tblPr>
               <a:tblGrid>
-                <a:gridCol w="1280160"/>
-                <a:gridCol w="1280160"/>
-                <a:gridCol w="1280160"/>
-                <a:gridCol w="1280160"/>
-                <a:gridCol w="1280160"/>
+                <a:gridCol w="1280160">
+                  <a:extLst>
+                    <a:ext uri="{9D8B030D-6E8A-4147-A177-3AD203B41FA5}">
+                      <a16:colId xmlns:a16="http://schemas.microsoft.com/office/drawing/2014/main" val="20000"/>
+                    </a:ext>
+                  </a:extLst>
+                </a:gridCol>
+                <a:gridCol w="1280160">
+                  <a:extLst>
+                    <a:ext uri="{9D8B030D-6E8A-4147-A177-3AD203B41FA5}">
+                      <a16:colId xmlns:a16="http://schemas.microsoft.com/office/drawing/2014/main" val="20001"/>
+                    </a:ext>
+                  </a:extLst>
+                </a:gridCol>
+                <a:gridCol w="1280160">
+                  <a:extLst>
+                    <a:ext uri="{9D8B030D-6E8A-4147-A177-3AD203B41FA5}">
+                      <a16:colId xmlns:a16="http://schemas.microsoft.com/office/drawing/2014/main" val="20002"/>
+                    </a:ext>
+                  </a:extLst>
+                </a:gridCol>
+                <a:gridCol w="1280160">
+                  <a:extLst>
+                    <a:ext uri="{9D8B030D-6E8A-4147-A177-3AD203B41FA5}">
+                      <a16:colId xmlns:a16="http://schemas.microsoft.com/office/drawing/2014/main" val="20003"/>
+                    </a:ext>
+                  </a:extLst>
+                </a:gridCol>
+                <a:gridCol w="1280160">
+                  <a:extLst>
+                    <a:ext uri="{9D8B030D-6E8A-4147-A177-3AD203B41FA5}">
+                      <a16:colId xmlns:a16="http://schemas.microsoft.com/office/drawing/2014/main" val="20004"/>
+                    </a:ext>
+                  </a:extLst>
+                </a:gridCol>
               </a:tblGrid>
               <a:tr h="411480">
                 <a:tc>
@@ -4212,7 +4265,7 @@
                     <a:lstStyle/>
                     <a:p>
                       <a:pPr>
-                        <a:defRPr b="1" sz="1000"/>
+                        <a:defRPr sz="1000" b="1"/>
                       </a:pPr>
                       <a:r>
                         <a:t>数据</a:t>
@@ -4231,7 +4284,7 @@
                     <a:lstStyle/>
                     <a:p>
                       <a:pPr>
-                        <a:defRPr b="1" sz="1000"/>
+                        <a:defRPr sz="1000" b="1"/>
                       </a:pPr>
                       <a:r>
                         <a:t>Acc</a:t>
@@ -4250,7 +4303,7 @@
                     <a:lstStyle/>
                     <a:p>
                       <a:pPr>
-                        <a:defRPr b="1" sz="1000"/>
+                        <a:defRPr sz="1000" b="1"/>
                       </a:pPr>
                       <a:r>
                         <a:t>Precision</a:t>
@@ -4269,7 +4322,7 @@
                     <a:lstStyle/>
                     <a:p>
                       <a:pPr>
-                        <a:defRPr b="1" sz="1000"/>
+                        <a:defRPr sz="1000" b="1"/>
                       </a:pPr>
                       <a:r>
                         <a:t>Recall</a:t>
@@ -4288,7 +4341,7 @@
                     <a:lstStyle/>
                     <a:p>
                       <a:pPr>
-                        <a:defRPr b="1" sz="1000"/>
+                        <a:defRPr sz="1000" b="1"/>
                       </a:pPr>
                       <a:r>
                         <a:t>F1</a:t>
@@ -4301,6 +4354,11 @@
                     </a:solidFill>
                   </a:tcPr>
                 </a:tc>
+                <a:extLst>
+                  <a:ext uri="{0D108BD9-81ED-4DB2-BD59-A6C34878D82A}">
+                    <a16:rowId xmlns:a16="http://schemas.microsoft.com/office/drawing/2014/main" val="10000"/>
+                  </a:ext>
+                </a:extLst>
               </a:tr>
               <a:tr h="411480">
                 <a:tc>
@@ -4378,6 +4436,11 @@
                   </a:txBody>
                   <a:tcPr/>
                 </a:tc>
+                <a:extLst>
+                  <a:ext uri="{0D108BD9-81ED-4DB2-BD59-A6C34878D82A}">
+                    <a16:rowId xmlns:a16="http://schemas.microsoft.com/office/drawing/2014/main" val="10001"/>
+                  </a:ext>
+                </a:extLst>
               </a:tr>
               <a:tr h="411480">
                 <a:tc>
@@ -4455,6 +4518,11 @@
                   </a:txBody>
                   <a:tcPr/>
                 </a:tc>
+                <a:extLst>
+                  <a:ext uri="{0D108BD9-81ED-4DB2-BD59-A6C34878D82A}">
+                    <a16:rowId xmlns:a16="http://schemas.microsoft.com/office/drawing/2014/main" val="10002"/>
+                  </a:ext>
+                </a:extLst>
               </a:tr>
               <a:tr h="411480">
                 <a:tc>
@@ -4532,6 +4600,11 @@
                   </a:txBody>
                   <a:tcPr/>
                 </a:tc>
+                <a:extLst>
+                  <a:ext uri="{0D108BD9-81ED-4DB2-BD59-A6C34878D82A}">
+                    <a16:rowId xmlns:a16="http://schemas.microsoft.com/office/drawing/2014/main" val="10003"/>
+                  </a:ext>
+                </a:extLst>
               </a:tr>
             </a:tbl>
           </a:graphicData>
@@ -4579,6 +4652,7 @@
           <a:lstStyle/>
           <a:p>
             <a:pPr algn="ctr"/>
+            <a:endParaRPr/>
           </a:p>
         </p:txBody>
       </p:sp>
@@ -4745,6 +4819,7 @@
           <a:lstStyle/>
           <a:p>
             <a:pPr algn="ctr"/>
+            <a:endParaRPr/>
           </a:p>
         </p:txBody>
       </p:sp>
@@ -4909,6 +4984,7 @@
           <a:lstStyle/>
           <a:p>
             <a:pPr algn="ctr"/>
+            <a:endParaRPr/>
           </a:p>
         </p:txBody>
       </p:sp>
@@ -4956,7 +5032,7 @@
 </file>
 
 <file path=ppt/slides/slide12.xml><?xml version="1.0" encoding="utf-8"?>
-<p:sld xmlns:a="http://schemas.openxmlformats.org/drawingml/2006/main" xmlns:p="http://schemas.openxmlformats.org/presentationml/2006/main" xmlns:r="http://schemas.openxmlformats.org/officeDocument/2006/relationships">
+<p:sld xmlns:a="http://schemas.openxmlformats.org/drawingml/2006/main" xmlns:r="http://schemas.openxmlformats.org/officeDocument/2006/relationships" xmlns:p="http://schemas.openxmlformats.org/presentationml/2006/main">
   <p:cSld>
     <p:bg>
       <p:bgPr>
@@ -4972,7 +5048,14 @@
         <p:cNvGrpSpPr/>
         <p:nvPr/>
       </p:nvGrpSpPr>
-      <p:grpSpPr/>
+      <p:grpSpPr>
+        <a:xfrm>
+          <a:off x="0" y="0"/>
+          <a:ext cx="0" cy="0"/>
+          <a:chOff x="0" y="0"/>
+          <a:chExt cx="0" cy="0"/>
+        </a:xfrm>
+      </p:grpSpPr>
       <p:sp>
         <p:nvSpPr>
           <p:cNvPr id="2" name="TextBox 1"/>
@@ -5083,6 +5166,7 @@
           <a:lstStyle/>
           <a:p>
             <a:pPr algn="ctr"/>
+            <a:endParaRPr/>
           </a:p>
         </p:txBody>
       </p:sp>
@@ -5140,13 +5224,13 @@
       </p:sp>
       <p:sp>
         <p:nvSpPr>
-          <p:cNvPr id="6" name="TextBox 5"/>
+          <p:cNvPr id="8" name="TextBox 7"/>
           <p:cNvSpPr txBox="1"/>
           <p:nvPr/>
         </p:nvSpPr>
         <p:spPr>
           <a:xfrm>
-            <a:off x="1417320" y="1664208"/>
+            <a:off x="1417320" y="1686283"/>
             <a:ext cx="9601200" cy="384048"/>
           </a:xfrm>
           <a:prstGeom prst="rect">
@@ -5172,20 +5256,49 @@
               </a:defRPr>
             </a:pPr>
             <a:r>
-              <a:t>pip 命令误连 → 分开执行 pip install -r 和 pip install -e</a:t>
-            </a:r>
-          </a:p>
-        </p:txBody>
-      </p:sp>
-      <p:sp>
-        <p:nvSpPr>
-          <p:cNvPr id="7" name="Rounded Rectangle 6"/>
+              <a:rPr dirty="0" err="1"/>
+              <a:t>TensorBoard</a:t>
+            </a:r>
+            <a:r>
+              <a:rPr dirty="0"/>
+              <a:t> </a:t>
+            </a:r>
+            <a:r>
+              <a:rPr dirty="0" err="1"/>
+              <a:t>提示缺少</a:t>
+            </a:r>
+            <a:r>
+              <a:rPr dirty="0"/>
+              <a:t> TensorFlow → </a:t>
+            </a:r>
+            <a:r>
+              <a:rPr dirty="0" err="1"/>
+              <a:t>PyTorch</a:t>
+            </a:r>
+            <a:r>
+              <a:rPr dirty="0"/>
+              <a:t> </a:t>
+            </a:r>
+            <a:r>
+              <a:rPr dirty="0" err="1"/>
+              <a:t>曲线仍可正常显示，无需安装</a:t>
+            </a:r>
+            <a:r>
+              <a:rPr dirty="0"/>
+              <a:t> TensorFlow</a:t>
+            </a:r>
+          </a:p>
+        </p:txBody>
+      </p:sp>
+      <p:sp>
+        <p:nvSpPr>
+          <p:cNvPr id="9" name="Rounded Rectangle 8"/>
           <p:cNvSpPr/>
           <p:nvPr/>
         </p:nvSpPr>
         <p:spPr>
           <a:xfrm>
-            <a:off x="960120" y="2377440"/>
+            <a:off x="960120" y="3063240"/>
             <a:ext cx="320040" cy="320040"/>
           </a:xfrm>
           <a:prstGeom prst="roundRect">
@@ -5218,7 +5331,7 @@
           <a:p>
             <a:pPr algn="ctr"/>
             <a:r>
-              <a:rPr sz="1000" b="1">
+              <a:rPr lang="en-US" sz="1000" b="1" dirty="0">
                 <a:solidFill>
                   <a:srgbClr val="FFFFFF"/>
                 </a:solidFill>
@@ -5226,18 +5339,24 @@
               </a:rPr>
               <a:t>2</a:t>
             </a:r>
-          </a:p>
-        </p:txBody>
-      </p:sp>
-      <p:sp>
-        <p:nvSpPr>
-          <p:cNvPr id="8" name="TextBox 7"/>
+            <a:endParaRPr sz="1000" b="1" dirty="0">
+              <a:solidFill>
+                <a:srgbClr val="FFFFFF"/>
+              </a:solidFill>
+              <a:latin typeface="Microsoft YaHei"/>
+            </a:endParaRPr>
+          </a:p>
+        </p:txBody>
+      </p:sp>
+      <p:sp>
+        <p:nvSpPr>
+          <p:cNvPr id="10" name="TextBox 9"/>
           <p:cNvSpPr txBox="1"/>
           <p:nvPr/>
         </p:nvSpPr>
         <p:spPr>
           <a:xfrm>
-            <a:off x="1417320" y="2350008"/>
+            <a:off x="1417320" y="3063240"/>
             <a:ext cx="9601200" cy="384048"/>
           </a:xfrm>
           <a:prstGeom prst="rect">
@@ -5263,20 +5382,106 @@
               </a:defRPr>
             </a:pPr>
             <a:r>
-              <a:t>TensorBoard 提示缺少 TensorFlow → PyTorch 曲线仍可正常显示，无需安装 TensorFlow</a:t>
-            </a:r>
-          </a:p>
-        </p:txBody>
-      </p:sp>
-      <p:sp>
-        <p:nvSpPr>
-          <p:cNvPr id="9" name="Rounded Rectangle 8"/>
+              <a:rPr dirty="0"/>
+              <a:t>ONNX </a:t>
+            </a:r>
+            <a:r>
+              <a:rPr dirty="0" err="1"/>
+              <a:t>缺少依赖</a:t>
+            </a:r>
+            <a:r>
+              <a:rPr dirty="0"/>
+              <a:t> → </a:t>
+            </a:r>
+            <a:r>
+              <a:rPr dirty="0" err="1"/>
+              <a:t>补充</a:t>
+            </a:r>
+            <a:r>
+              <a:rPr dirty="0"/>
+              <a:t> </a:t>
+            </a:r>
+            <a:r>
+              <a:rPr dirty="0" err="1"/>
+              <a:t>onnx、onnxscript、onnxruntime</a:t>
+            </a:r>
+            <a:endParaRPr dirty="0"/>
+          </a:p>
+        </p:txBody>
+      </p:sp>
+      <p:sp>
+        <p:nvSpPr>
+          <p:cNvPr id="12" name="TextBox 11"/>
+          <p:cNvSpPr txBox="1"/>
+          <p:nvPr/>
+        </p:nvSpPr>
+        <p:spPr>
+          <a:xfrm>
+            <a:off x="1417320" y="4431330"/>
+            <a:ext cx="9601200" cy="384048"/>
+          </a:xfrm>
+          <a:prstGeom prst="rect">
+            <a:avLst/>
+          </a:prstGeom>
+          <a:noFill/>
+        </p:spPr>
+        <p:txBody>
+          <a:bodyPr wrap="square">
+            <a:spAutoFit/>
+          </a:bodyPr>
+          <a:lstStyle/>
+          <a:p>
+            <a:pPr>
+              <a:spcAft>
+                <a:spcPts val="600"/>
+              </a:spcAft>
+              <a:defRPr sz="1300">
+                <a:solidFill>
+                  <a:srgbClr val="141F2B"/>
+                </a:solidFill>
+                <a:latin typeface="Microsoft YaHei"/>
+              </a:defRPr>
+            </a:pPr>
+            <a:r>
+              <a:rPr dirty="0"/>
+              <a:t>Windows </a:t>
+            </a:r>
+            <a:r>
+              <a:rPr dirty="0" err="1"/>
+              <a:t>中文终端导出编码问题</a:t>
+            </a:r>
+            <a:r>
+              <a:rPr dirty="0"/>
+              <a:t> → </a:t>
+            </a:r>
+            <a:r>
+              <a:rPr dirty="0" err="1"/>
+              <a:t>使用</a:t>
+            </a:r>
+            <a:r>
+              <a:rPr dirty="0"/>
+              <a:t> legacy ONNX </a:t>
+            </a:r>
+            <a:r>
+              <a:rPr dirty="0" err="1"/>
+              <a:t>export，dynamo</a:t>
+            </a:r>
+            <a:r>
+              <a:rPr dirty="0"/>
+              <a:t>=False</a:t>
+            </a:r>
+          </a:p>
+        </p:txBody>
+      </p:sp>
+      <p:sp>
+        <p:nvSpPr>
+          <p:cNvPr id="13" name="Rounded Rectangle 12"/>
           <p:cNvSpPr/>
           <p:nvPr/>
         </p:nvSpPr>
         <p:spPr>
           <a:xfrm>
-            <a:off x="960120" y="3063240"/>
+            <a:off x="960120" y="4434840"/>
             <a:ext cx="320040" cy="320040"/>
           </a:xfrm>
           <a:prstGeom prst="roundRect">
@@ -5309,7 +5514,7 @@
           <a:p>
             <a:pPr algn="ctr"/>
             <a:r>
-              <a:rPr sz="1000" b="1">
+              <a:rPr lang="en-US" sz="1000" b="1" dirty="0">
                 <a:solidFill>
                   <a:srgbClr val="FFFFFF"/>
                 </a:solidFill>
@@ -5317,227 +5522,12 @@
               </a:rPr>
               <a:t>3</a:t>
             </a:r>
-          </a:p>
-        </p:txBody>
-      </p:sp>
-      <p:sp>
-        <p:nvSpPr>
-          <p:cNvPr id="10" name="TextBox 9"/>
-          <p:cNvSpPr txBox="1"/>
-          <p:nvPr/>
-        </p:nvSpPr>
-        <p:spPr>
-          <a:xfrm>
-            <a:off x="1417320" y="3035808"/>
-            <a:ext cx="9601200" cy="384048"/>
-          </a:xfrm>
-          <a:prstGeom prst="rect">
-            <a:avLst/>
-          </a:prstGeom>
-          <a:noFill/>
-        </p:spPr>
-        <p:txBody>
-          <a:bodyPr wrap="square">
-            <a:spAutoFit/>
-          </a:bodyPr>
-          <a:lstStyle/>
-          <a:p>
-            <a:pPr>
-              <a:spcAft>
-                <a:spcPts val="600"/>
-              </a:spcAft>
-              <a:defRPr sz="1300">
-                <a:solidFill>
-                  <a:srgbClr val="141F2B"/>
-                </a:solidFill>
-                <a:latin typeface="Microsoft YaHei"/>
-              </a:defRPr>
-            </a:pPr>
-            <a:r>
-              <a:t>ONNX 缺少依赖 → 补充 onnx、onnxscript、onnxruntime</a:t>
-            </a:r>
-          </a:p>
-        </p:txBody>
-      </p:sp>
-      <p:sp>
-        <p:nvSpPr>
-          <p:cNvPr id="11" name="Rounded Rectangle 10"/>
-          <p:cNvSpPr/>
-          <p:nvPr/>
-        </p:nvSpPr>
-        <p:spPr>
-          <a:xfrm>
-            <a:off x="960120" y="3749040"/>
-            <a:ext cx="320040" cy="320040"/>
-          </a:xfrm>
-          <a:prstGeom prst="roundRect">
-            <a:avLst/>
-          </a:prstGeom>
-          <a:solidFill>
-            <a:srgbClr val="2563EB"/>
-          </a:solidFill>
-          <a:ln>
-            <a:noFill/>
-          </a:ln>
-        </p:spPr>
-        <p:style>
-          <a:lnRef idx="1">
-            <a:schemeClr val="accent1"/>
-          </a:lnRef>
-          <a:fillRef idx="3">
-            <a:schemeClr val="accent1"/>
-          </a:fillRef>
-          <a:effectRef idx="2">
-            <a:schemeClr val="accent1"/>
-          </a:effectRef>
-          <a:fontRef idx="minor">
-            <a:schemeClr val="lt1"/>
-          </a:fontRef>
-        </p:style>
-        <p:txBody>
-          <a:bodyPr rtlCol="0" anchor="ctr"/>
-          <a:lstStyle/>
-          <a:p>
-            <a:pPr algn="ctr"/>
-            <a:r>
-              <a:rPr sz="1000" b="1">
-                <a:solidFill>
-                  <a:srgbClr val="FFFFFF"/>
-                </a:solidFill>
-                <a:latin typeface="Microsoft YaHei"/>
-              </a:rPr>
-              <a:t>4</a:t>
-            </a:r>
-          </a:p>
-        </p:txBody>
-      </p:sp>
-      <p:sp>
-        <p:nvSpPr>
-          <p:cNvPr id="12" name="TextBox 11"/>
-          <p:cNvSpPr txBox="1"/>
-          <p:nvPr/>
-        </p:nvSpPr>
-        <p:spPr>
-          <a:xfrm>
-            <a:off x="1417320" y="3721608"/>
-            <a:ext cx="9601200" cy="384048"/>
-          </a:xfrm>
-          <a:prstGeom prst="rect">
-            <a:avLst/>
-          </a:prstGeom>
-          <a:noFill/>
-        </p:spPr>
-        <p:txBody>
-          <a:bodyPr wrap="square">
-            <a:spAutoFit/>
-          </a:bodyPr>
-          <a:lstStyle/>
-          <a:p>
-            <a:pPr>
-              <a:spcAft>
-                <a:spcPts val="600"/>
-              </a:spcAft>
-              <a:defRPr sz="1300">
-                <a:solidFill>
-                  <a:srgbClr val="141F2B"/>
-                </a:solidFill>
-                <a:latin typeface="Microsoft YaHei"/>
-              </a:defRPr>
-            </a:pPr>
-            <a:r>
-              <a:t>Windows 中文终端导出编码问题 → 使用 legacy ONNX export，dynamo=False</a:t>
-            </a:r>
-          </a:p>
-        </p:txBody>
-      </p:sp>
-      <p:sp>
-        <p:nvSpPr>
-          <p:cNvPr id="13" name="Rounded Rectangle 12"/>
-          <p:cNvSpPr/>
-          <p:nvPr/>
-        </p:nvSpPr>
-        <p:spPr>
-          <a:xfrm>
-            <a:off x="960120" y="4434840"/>
-            <a:ext cx="320040" cy="320040"/>
-          </a:xfrm>
-          <a:prstGeom prst="roundRect">
-            <a:avLst/>
-          </a:prstGeom>
-          <a:solidFill>
-            <a:srgbClr val="2563EB"/>
-          </a:solidFill>
-          <a:ln>
-            <a:noFill/>
-          </a:ln>
-        </p:spPr>
-        <p:style>
-          <a:lnRef idx="1">
-            <a:schemeClr val="accent1"/>
-          </a:lnRef>
-          <a:fillRef idx="3">
-            <a:schemeClr val="accent1"/>
-          </a:fillRef>
-          <a:effectRef idx="2">
-            <a:schemeClr val="accent1"/>
-          </a:effectRef>
-          <a:fontRef idx="minor">
-            <a:schemeClr val="lt1"/>
-          </a:fontRef>
-        </p:style>
-        <p:txBody>
-          <a:bodyPr rtlCol="0" anchor="ctr"/>
-          <a:lstStyle/>
-          <a:p>
-            <a:pPr algn="ctr"/>
-            <a:r>
-              <a:rPr sz="1000" b="1">
-                <a:solidFill>
-                  <a:srgbClr val="FFFFFF"/>
-                </a:solidFill>
-                <a:latin typeface="Microsoft YaHei"/>
-              </a:rPr>
-              <a:t>5</a:t>
-            </a:r>
-          </a:p>
-        </p:txBody>
-      </p:sp>
-      <p:sp>
-        <p:nvSpPr>
-          <p:cNvPr id="14" name="TextBox 13"/>
-          <p:cNvSpPr txBox="1"/>
-          <p:nvPr/>
-        </p:nvSpPr>
-        <p:spPr>
-          <a:xfrm>
-            <a:off x="1417320" y="4407408"/>
-            <a:ext cx="9601200" cy="384048"/>
-          </a:xfrm>
-          <a:prstGeom prst="rect">
-            <a:avLst/>
-          </a:prstGeom>
-          <a:noFill/>
-        </p:spPr>
-        <p:txBody>
-          <a:bodyPr wrap="square">
-            <a:spAutoFit/>
-          </a:bodyPr>
-          <a:lstStyle/>
-          <a:p>
-            <a:pPr>
-              <a:spcAft>
-                <a:spcPts val="600"/>
-              </a:spcAft>
-              <a:defRPr sz="1300">
-                <a:solidFill>
-                  <a:srgbClr val="141F2B"/>
-                </a:solidFill>
-                <a:latin typeface="Microsoft YaHei"/>
-              </a:defRPr>
-            </a:pPr>
-            <a:r>
-              <a:t>GitHub workflow 权限不足 → 移除非必要 CI 文件后成功 push</a:t>
-            </a:r>
+            <a:endParaRPr sz="1000" b="1" dirty="0">
+              <a:solidFill>
+                <a:srgbClr val="FFFFFF"/>
+              </a:solidFill>
+              <a:latin typeface="Microsoft YaHei"/>
+            </a:endParaRPr>
           </a:p>
         </p:txBody>
       </p:sp>
@@ -5581,6 +5571,7 @@
           <a:lstStyle/>
           <a:p>
             <a:pPr algn="ctr"/>
+            <a:endParaRPr/>
           </a:p>
         </p:txBody>
       </p:sp>
@@ -5628,7 +5619,7 @@
 </file>
 
 <file path=ppt/slides/slide13.xml><?xml version="1.0" encoding="utf-8"?>
-<p:sld xmlns:a="http://schemas.openxmlformats.org/drawingml/2006/main" xmlns:p="http://schemas.openxmlformats.org/presentationml/2006/main" xmlns:r="http://schemas.openxmlformats.org/officeDocument/2006/relationships">
+<p:sld xmlns:a="http://schemas.openxmlformats.org/drawingml/2006/main" xmlns:r="http://schemas.openxmlformats.org/officeDocument/2006/relationships" xmlns:p="http://schemas.openxmlformats.org/presentationml/2006/main">
   <p:cSld>
     <p:bg>
       <p:bgPr>
@@ -5644,7 +5635,14 @@
         <p:cNvGrpSpPr/>
         <p:nvPr/>
       </p:nvGrpSpPr>
-      <p:grpSpPr/>
+      <p:grpSpPr>
+        <a:xfrm>
+          <a:off x="0" y="0"/>
+          <a:ext cx="0" cy="0"/>
+          <a:chOff x="0" y="0"/>
+          <a:chExt cx="0" cy="0"/>
+        </a:xfrm>
+      </p:grpSpPr>
       <p:sp>
         <p:nvSpPr>
           <p:cNvPr id="2" name="TextBox 1"/>
@@ -5755,6 +5753,7 @@
           <a:lstStyle/>
           <a:p>
             <a:pPr algn="ctr"/>
+            <a:endParaRPr/>
           </a:p>
         </p:txBody>
       </p:sp>
@@ -5937,6 +5936,7 @@
           <a:lstStyle/>
           <a:p>
             <a:pPr algn="ctr"/>
+            <a:endParaRPr/>
           </a:p>
         </p:txBody>
       </p:sp>
@@ -6117,6 +6117,7 @@
           <a:lstStyle/>
           <a:p>
             <a:pPr algn="ctr"/>
+            <a:endParaRPr/>
           </a:p>
         </p:txBody>
       </p:sp>
@@ -6164,7 +6165,7 @@
 </file>
 
 <file path=ppt/slides/slide14.xml><?xml version="1.0" encoding="utf-8"?>
-<p:sld xmlns:a="http://schemas.openxmlformats.org/drawingml/2006/main" xmlns:p="http://schemas.openxmlformats.org/presentationml/2006/main" xmlns:r="http://schemas.openxmlformats.org/officeDocument/2006/relationships">
+<p:sld xmlns:a="http://schemas.openxmlformats.org/drawingml/2006/main" xmlns:r="http://schemas.openxmlformats.org/officeDocument/2006/relationships" xmlns:p="http://schemas.openxmlformats.org/presentationml/2006/main">
   <p:cSld>
     <p:bg>
       <p:bgPr>
@@ -6180,7 +6181,14 @@
         <p:cNvGrpSpPr/>
         <p:nvPr/>
       </p:nvGrpSpPr>
-      <p:grpSpPr/>
+      <p:grpSpPr>
+        <a:xfrm>
+          <a:off x="0" y="0"/>
+          <a:ext cx="0" cy="0"/>
+          <a:chOff x="0" y="0"/>
+          <a:chExt cx="0" cy="0"/>
+        </a:xfrm>
+      </p:grpSpPr>
       <p:sp>
         <p:nvSpPr>
           <p:cNvPr id="2" name="TextBox 1"/>
@@ -6291,6 +6299,7 @@
           <a:lstStyle/>
           <a:p>
             <a:pPr algn="ctr"/>
+            <a:endParaRPr/>
           </a:p>
         </p:txBody>
       </p:sp>
@@ -6473,6 +6482,7 @@
           <a:lstStyle/>
           <a:p>
             <a:pPr algn="ctr"/>
+            <a:endParaRPr/>
           </a:p>
         </p:txBody>
       </p:sp>
@@ -6653,6 +6663,7 @@
           <a:lstStyle/>
           <a:p>
             <a:pPr algn="ctr"/>
+            <a:endParaRPr/>
           </a:p>
         </p:txBody>
       </p:sp>
@@ -6700,7 +6711,7 @@
 </file>
 
 <file path=ppt/slides/slide2.xml><?xml version="1.0" encoding="utf-8"?>
-<p:sld xmlns:a="http://schemas.openxmlformats.org/drawingml/2006/main" xmlns:p="http://schemas.openxmlformats.org/presentationml/2006/main" xmlns:r="http://schemas.openxmlformats.org/officeDocument/2006/relationships">
+<p:sld xmlns:a="http://schemas.openxmlformats.org/drawingml/2006/main" xmlns:r="http://schemas.openxmlformats.org/officeDocument/2006/relationships" xmlns:p="http://schemas.openxmlformats.org/presentationml/2006/main">
   <p:cSld>
     <p:bg>
       <p:bgPr>
@@ -6716,7 +6727,14 @@
         <p:cNvGrpSpPr/>
         <p:nvPr/>
       </p:nvGrpSpPr>
-      <p:grpSpPr/>
+      <p:grpSpPr>
+        <a:xfrm>
+          <a:off x="0" y="0"/>
+          <a:ext cx="0" cy="0"/>
+          <a:chOff x="0" y="0"/>
+          <a:chExt cx="0" cy="0"/>
+        </a:xfrm>
+      </p:grpSpPr>
       <p:sp>
         <p:nvSpPr>
           <p:cNvPr id="2" name="TextBox 1"/>
@@ -6827,6 +6845,7 @@
           <a:lstStyle/>
           <a:p>
             <a:pPr algn="ctr"/>
+            <a:endParaRPr/>
           </a:p>
         </p:txBody>
       </p:sp>
@@ -6993,6 +7012,7 @@
           <a:lstStyle/>
           <a:p>
             <a:pPr algn="ctr"/>
+            <a:endParaRPr/>
           </a:p>
         </p:txBody>
       </p:sp>
@@ -7157,6 +7177,7 @@
           <a:lstStyle/>
           <a:p>
             <a:pPr algn="ctr"/>
+            <a:endParaRPr/>
           </a:p>
         </p:txBody>
       </p:sp>
@@ -7204,7 +7225,7 @@
 </file>
 
 <file path=ppt/slides/slide3.xml><?xml version="1.0" encoding="utf-8"?>
-<p:sld xmlns:a="http://schemas.openxmlformats.org/drawingml/2006/main" xmlns:p="http://schemas.openxmlformats.org/presentationml/2006/main" xmlns:r="http://schemas.openxmlformats.org/officeDocument/2006/relationships">
+<p:sld xmlns:a="http://schemas.openxmlformats.org/drawingml/2006/main" xmlns:r="http://schemas.openxmlformats.org/officeDocument/2006/relationships" xmlns:p="http://schemas.openxmlformats.org/presentationml/2006/main">
   <p:cSld>
     <p:bg>
       <p:bgPr>
@@ -7220,7 +7241,14 @@
         <p:cNvGrpSpPr/>
         <p:nvPr/>
       </p:nvGrpSpPr>
-      <p:grpSpPr/>
+      <p:grpSpPr>
+        <a:xfrm>
+          <a:off x="0" y="0"/>
+          <a:ext cx="0" cy="0"/>
+          <a:chOff x="0" y="0"/>
+          <a:chExt cx="0" cy="0"/>
+        </a:xfrm>
+      </p:grpSpPr>
       <p:sp>
         <p:nvSpPr>
           <p:cNvPr id="2" name="TextBox 1"/>
@@ -7382,6 +7410,7 @@
           <a:lstStyle/>
           <a:p>
             <a:pPr algn="ctr"/>
+            <a:endParaRPr/>
           </a:p>
         </p:txBody>
       </p:sp>
@@ -7478,6 +7507,7 @@
           <a:lstStyle/>
           <a:p>
             <a:pPr algn="ctr"/>
+            <a:endParaRPr/>
           </a:p>
         </p:txBody>
       </p:sp>
@@ -7574,6 +7604,7 @@
           <a:lstStyle/>
           <a:p>
             <a:pPr algn="ctr"/>
+            <a:endParaRPr/>
           </a:p>
         </p:txBody>
       </p:sp>
@@ -7670,6 +7701,7 @@
           <a:lstStyle/>
           <a:p>
             <a:pPr algn="ctr"/>
+            <a:endParaRPr/>
           </a:p>
         </p:txBody>
       </p:sp>
@@ -7766,6 +7798,7 @@
           <a:lstStyle/>
           <a:p>
             <a:pPr algn="ctr"/>
+            <a:endParaRPr/>
           </a:p>
         </p:txBody>
       </p:sp>
@@ -7862,6 +7895,7 @@
           <a:lstStyle/>
           <a:p>
             <a:pPr algn="ctr"/>
+            <a:endParaRPr/>
           </a:p>
         </p:txBody>
       </p:sp>
@@ -8029,6 +8063,7 @@
           <a:lstStyle/>
           <a:p>
             <a:pPr algn="ctr"/>
+            <a:endParaRPr/>
           </a:p>
         </p:txBody>
       </p:sp>
@@ -8076,7 +8111,7 @@
 </file>
 
 <file path=ppt/slides/slide4.xml><?xml version="1.0" encoding="utf-8"?>
-<p:sld xmlns:a="http://schemas.openxmlformats.org/drawingml/2006/main" xmlns:p="http://schemas.openxmlformats.org/presentationml/2006/main" xmlns:r="http://schemas.openxmlformats.org/officeDocument/2006/relationships">
+<p:sld xmlns:a="http://schemas.openxmlformats.org/drawingml/2006/main" xmlns:r="http://schemas.openxmlformats.org/officeDocument/2006/relationships" xmlns:p="http://schemas.openxmlformats.org/presentationml/2006/main">
   <p:cSld>
     <p:bg>
       <p:bgPr>
@@ -8092,7 +8127,14 @@
         <p:cNvGrpSpPr/>
         <p:nvPr/>
       </p:nvGrpSpPr>
-      <p:grpSpPr/>
+      <p:grpSpPr>
+        <a:xfrm>
+          <a:off x="0" y="0"/>
+          <a:ext cx="0" cy="0"/>
+          <a:chOff x="0" y="0"/>
+          <a:chExt cx="0" cy="0"/>
+        </a:xfrm>
+      </p:grpSpPr>
       <p:sp>
         <p:nvSpPr>
           <p:cNvPr id="2" name="TextBox 1"/>
@@ -8203,6 +8245,7 @@
           <a:lstStyle/>
           <a:p>
             <a:pPr algn="ctr"/>
+            <a:endParaRPr/>
           </a:p>
         </p:txBody>
       </p:sp>
@@ -8276,7 +8319,7 @@
           </a:fontRef>
         </p:style>
         <p:txBody>
-          <a:bodyPr rtlCol="0" anchor="ctr" lIns="109728" rIns="109728" tIns="73152"/>
+          <a:bodyPr lIns="109728" tIns="73152" rIns="109728" rtlCol="0" anchor="ctr"/>
           <a:lstStyle/>
           <a:p>
             <a:pPr algn="ctr"/>
@@ -8425,6 +8468,7 @@
           <a:lstStyle/>
           <a:p>
             <a:pPr algn="ctr"/>
+            <a:endParaRPr/>
           </a:p>
         </p:txBody>
       </p:sp>
@@ -8555,6 +8599,7 @@
           <a:lstStyle/>
           <a:p>
             <a:pPr algn="ctr"/>
+            <a:endParaRPr/>
           </a:p>
         </p:txBody>
       </p:sp>
@@ -8651,6 +8696,7 @@
           <a:lstStyle/>
           <a:p>
             <a:pPr algn="ctr"/>
+            <a:endParaRPr/>
           </a:p>
         </p:txBody>
       </p:sp>
@@ -8747,6 +8793,7 @@
           <a:lstStyle/>
           <a:p>
             <a:pPr algn="ctr"/>
+            <a:endParaRPr/>
           </a:p>
         </p:txBody>
       </p:sp>
@@ -8914,6 +8961,7 @@
           <a:lstStyle/>
           <a:p>
             <a:pPr algn="ctr"/>
+            <a:endParaRPr/>
           </a:p>
         </p:txBody>
       </p:sp>
@@ -8961,7 +9009,7 @@
 </file>
 
 <file path=ppt/slides/slide5.xml><?xml version="1.0" encoding="utf-8"?>
-<p:sld xmlns:a="http://schemas.openxmlformats.org/drawingml/2006/main" xmlns:p="http://schemas.openxmlformats.org/presentationml/2006/main" xmlns:r="http://schemas.openxmlformats.org/officeDocument/2006/relationships">
+<p:sld xmlns:a="http://schemas.openxmlformats.org/drawingml/2006/main" xmlns:r="http://schemas.openxmlformats.org/officeDocument/2006/relationships" xmlns:p="http://schemas.openxmlformats.org/presentationml/2006/main">
   <p:cSld>
     <p:bg>
       <p:bgPr>
@@ -8977,7 +9025,14 @@
         <p:cNvGrpSpPr/>
         <p:nvPr/>
       </p:nvGrpSpPr>
-      <p:grpSpPr/>
+      <p:grpSpPr>
+        <a:xfrm>
+          <a:off x="0" y="0"/>
+          <a:ext cx="0" cy="0"/>
+          <a:chOff x="0" y="0"/>
+          <a:chExt cx="0" cy="0"/>
+        </a:xfrm>
+      </p:grpSpPr>
       <p:sp>
         <p:nvSpPr>
           <p:cNvPr id="2" name="TextBox 1"/>
@@ -9139,6 +9194,7 @@
           <a:lstStyle/>
           <a:p>
             <a:pPr algn="ctr"/>
+            <a:endParaRPr/>
           </a:p>
         </p:txBody>
       </p:sp>
@@ -9235,6 +9291,7 @@
           <a:lstStyle/>
           <a:p>
             <a:pPr algn="ctr"/>
+            <a:endParaRPr/>
           </a:p>
         </p:txBody>
       </p:sp>
@@ -9331,6 +9388,7 @@
           <a:lstStyle/>
           <a:p>
             <a:pPr algn="ctr"/>
+            <a:endParaRPr/>
           </a:p>
         </p:txBody>
       </p:sp>
@@ -9427,6 +9485,7 @@
           <a:lstStyle/>
           <a:p>
             <a:pPr algn="ctr"/>
+            <a:endParaRPr/>
           </a:p>
         </p:txBody>
       </p:sp>
@@ -9523,6 +9582,7 @@
           <a:lstStyle/>
           <a:p>
             <a:pPr algn="ctr"/>
+            <a:endParaRPr/>
           </a:p>
         </p:txBody>
       </p:sp>
@@ -9619,6 +9679,7 @@
           <a:lstStyle/>
           <a:p>
             <a:pPr algn="ctr"/>
+            <a:endParaRPr/>
           </a:p>
         </p:txBody>
       </p:sp>
@@ -9717,6 +9778,7 @@
           <a:lstStyle/>
           <a:p>
             <a:pPr algn="ctr"/>
+            <a:endParaRPr/>
           </a:p>
         </p:txBody>
       </p:sp>
@@ -9877,7 +9939,7 @@
           </a:fontRef>
         </p:style>
         <p:txBody>
-          <a:bodyPr rtlCol="0" anchor="ctr" lIns="109728" rIns="109728" tIns="73152"/>
+          <a:bodyPr lIns="109728" tIns="73152" rIns="109728" rtlCol="0" anchor="ctr"/>
           <a:lstStyle/>
           <a:p>
             <a:pPr algn="ctr"/>
@@ -9936,6 +9998,7 @@
           <a:lstStyle/>
           <a:p>
             <a:pPr algn="ctr"/>
+            <a:endParaRPr/>
           </a:p>
         </p:txBody>
       </p:sp>
@@ -9983,7 +10046,7 @@
 </file>
 
 <file path=ppt/slides/slide6.xml><?xml version="1.0" encoding="utf-8"?>
-<p:sld xmlns:a="http://schemas.openxmlformats.org/drawingml/2006/main" xmlns:p="http://schemas.openxmlformats.org/presentationml/2006/main" xmlns:r="http://schemas.openxmlformats.org/officeDocument/2006/relationships">
+<p:sld xmlns:a="http://schemas.openxmlformats.org/drawingml/2006/main" xmlns:r="http://schemas.openxmlformats.org/officeDocument/2006/relationships" xmlns:p="http://schemas.openxmlformats.org/presentationml/2006/main">
   <p:cSld>
     <p:bg>
       <p:bgPr>
@@ -9999,7 +10062,14 @@
         <p:cNvGrpSpPr/>
         <p:nvPr/>
       </p:nvGrpSpPr>
-      <p:grpSpPr/>
+      <p:grpSpPr>
+        <a:xfrm>
+          <a:off x="0" y="0"/>
+          <a:ext cx="0" cy="0"/>
+          <a:chOff x="0" y="0"/>
+          <a:chExt cx="0" cy="0"/>
+        </a:xfrm>
+      </p:grpSpPr>
       <p:sp>
         <p:nvSpPr>
           <p:cNvPr id="2" name="TextBox 1"/>
@@ -10110,6 +10180,7 @@
           <a:lstStyle/>
           <a:p>
             <a:pPr algn="ctr"/>
+            <a:endParaRPr/>
           </a:p>
         </p:txBody>
       </p:sp>
@@ -10308,6 +10379,7 @@
           <a:lstStyle/>
           <a:p>
             <a:pPr algn="ctr"/>
+            <a:endParaRPr/>
           </a:p>
         </p:txBody>
       </p:sp>
@@ -10468,7 +10540,7 @@
           </a:fontRef>
         </p:style>
         <p:txBody>
-          <a:bodyPr rtlCol="0" anchor="ctr" lIns="109728" rIns="109728" tIns="73152"/>
+          <a:bodyPr lIns="109728" tIns="73152" rIns="109728" rtlCol="0" anchor="ctr"/>
           <a:lstStyle/>
           <a:p>
             <a:pPr algn="ctr"/>
@@ -10526,6 +10598,7 @@
           <a:lstStyle/>
           <a:p>
             <a:pPr algn="ctr"/>
+            <a:endParaRPr/>
           </a:p>
         </p:txBody>
       </p:sp>
@@ -10573,7 +10646,7 @@
 </file>
 
 <file path=ppt/slides/slide7.xml><?xml version="1.0" encoding="utf-8"?>
-<p:sld xmlns:a="http://schemas.openxmlformats.org/drawingml/2006/main" xmlns:p="http://schemas.openxmlformats.org/presentationml/2006/main" xmlns:r="http://schemas.openxmlformats.org/officeDocument/2006/relationships">
+<p:sld xmlns:a="http://schemas.openxmlformats.org/drawingml/2006/main" xmlns:r="http://schemas.openxmlformats.org/officeDocument/2006/relationships" xmlns:p="http://schemas.openxmlformats.org/presentationml/2006/main">
   <p:cSld>
     <p:bg>
       <p:bgPr>
@@ -10589,7 +10662,14 @@
         <p:cNvGrpSpPr/>
         <p:nvPr/>
       </p:nvGrpSpPr>
-      <p:grpSpPr/>
+      <p:grpSpPr>
+        <a:xfrm>
+          <a:off x="0" y="0"/>
+          <a:ext cx="0" cy="0"/>
+          <a:chOff x="0" y="0"/>
+          <a:chExt cx="0" cy="0"/>
+        </a:xfrm>
+      </p:grpSpPr>
       <p:sp>
         <p:nvSpPr>
           <p:cNvPr id="2" name="TextBox 1"/>
@@ -10700,6 +10780,7 @@
           <a:lstStyle/>
           <a:p>
             <a:pPr algn="ctr"/>
+            <a:endParaRPr/>
           </a:p>
         </p:txBody>
       </p:sp>
@@ -10860,7 +10941,7 @@
           </a:fontRef>
         </p:style>
         <p:txBody>
-          <a:bodyPr rtlCol="0" anchor="ctr" lIns="109728" rIns="109728" tIns="73152"/>
+          <a:bodyPr lIns="109728" tIns="73152" rIns="109728" rtlCol="0" anchor="ctr"/>
           <a:lstStyle/>
           <a:p>
             <a:pPr algn="ctr"/>
@@ -10918,6 +10999,7 @@
           <a:lstStyle/>
           <a:p>
             <a:pPr algn="ctr"/>
+            <a:endParaRPr/>
           </a:p>
         </p:txBody>
       </p:sp>
@@ -11082,6 +11164,7 @@
           <a:lstStyle/>
           <a:p>
             <a:pPr algn="ctr"/>
+            <a:endParaRPr/>
           </a:p>
         </p:txBody>
       </p:sp>
@@ -11129,7 +11212,7 @@
 </file>
 
 <file path=ppt/slides/slide8.xml><?xml version="1.0" encoding="utf-8"?>
-<p:sld xmlns:a="http://schemas.openxmlformats.org/drawingml/2006/main" xmlns:p="http://schemas.openxmlformats.org/presentationml/2006/main" xmlns:r="http://schemas.openxmlformats.org/officeDocument/2006/relationships">
+<p:sld xmlns:a="http://schemas.openxmlformats.org/drawingml/2006/main" xmlns:r="http://schemas.openxmlformats.org/officeDocument/2006/relationships" xmlns:p="http://schemas.openxmlformats.org/presentationml/2006/main">
   <p:cSld>
     <p:bg>
       <p:bgPr>
@@ -11145,7 +11228,14 @@
         <p:cNvGrpSpPr/>
         <p:nvPr/>
       </p:nvGrpSpPr>
-      <p:grpSpPr/>
+      <p:grpSpPr>
+        <a:xfrm>
+          <a:off x="0" y="0"/>
+          <a:ext cx="0" cy="0"/>
+          <a:chOff x="0" y="0"/>
+          <a:chExt cx="0" cy="0"/>
+        </a:xfrm>
+      </p:grpSpPr>
       <p:sp>
         <p:nvSpPr>
           <p:cNvPr id="2" name="TextBox 1"/>
@@ -11278,6 +11368,7 @@
           <a:lstStyle/>
           <a:p>
             <a:pPr algn="ctr"/>
+            <a:endParaRPr/>
           </a:p>
         </p:txBody>
       </p:sp>
@@ -11325,7 +11416,7 @@
 </file>
 
 <file path=ppt/slides/slide9.xml><?xml version="1.0" encoding="utf-8"?>
-<p:sld xmlns:a="http://schemas.openxmlformats.org/drawingml/2006/main" xmlns:p="http://schemas.openxmlformats.org/presentationml/2006/main" xmlns:r="http://schemas.openxmlformats.org/officeDocument/2006/relationships">
+<p:sld xmlns:a="http://schemas.openxmlformats.org/drawingml/2006/main" xmlns:r="http://schemas.openxmlformats.org/officeDocument/2006/relationships" xmlns:p="http://schemas.openxmlformats.org/presentationml/2006/main">
   <p:cSld>
     <p:bg>
       <p:bgPr>
@@ -11341,7 +11432,14 @@
         <p:cNvGrpSpPr/>
         <p:nvPr/>
       </p:nvGrpSpPr>
-      <p:grpSpPr/>
+      <p:grpSpPr>
+        <a:xfrm>
+          <a:off x="0" y="0"/>
+          <a:ext cx="0" cy="0"/>
+          <a:chOff x="0" y="0"/>
+          <a:chExt cx="0" cy="0"/>
+        </a:xfrm>
+      </p:grpSpPr>
       <p:sp>
         <p:nvSpPr>
           <p:cNvPr id="2" name="TextBox 1"/>
@@ -11503,6 +11601,7 @@
           <a:lstStyle/>
           <a:p>
             <a:pPr algn="ctr"/>
+            <a:endParaRPr/>
           </a:p>
         </p:txBody>
       </p:sp>
@@ -11598,6 +11697,7 @@
           <a:lstStyle/>
           <a:p>
             <a:pPr algn="ctr"/>
+            <a:endParaRPr/>
           </a:p>
         </p:txBody>
       </p:sp>
@@ -11693,6 +11793,7 @@
           <a:lstStyle/>
           <a:p>
             <a:pPr algn="ctr"/>
+            <a:endParaRPr/>
           </a:p>
         </p:txBody>
       </p:sp>
@@ -11788,6 +11889,7 @@
           <a:lstStyle/>
           <a:p>
             <a:pPr algn="ctr"/>
+            <a:endParaRPr/>
           </a:p>
         </p:txBody>
       </p:sp>
@@ -11886,6 +11988,7 @@
           <a:lstStyle/>
           <a:p>
             <a:pPr algn="ctr"/>
+            <a:endParaRPr/>
           </a:p>
         </p:txBody>
       </p:sp>
@@ -12046,7 +12149,7 @@
           </a:fontRef>
         </p:style>
         <p:txBody>
-          <a:bodyPr rtlCol="0" anchor="ctr" lIns="109728" rIns="109728" tIns="73152"/>
+          <a:bodyPr lIns="109728" tIns="73152" rIns="109728" rtlCol="0" anchor="ctr"/>
           <a:lstStyle/>
           <a:p>
             <a:pPr algn="ctr"/>
@@ -12104,6 +12207,7 @@
           <a:lstStyle/>
           <a:p>
             <a:pPr algn="ctr"/>
+            <a:endParaRPr/>
           </a:p>
         </p:txBody>
       </p:sp>

</xml_diff>